<commit_message>
Update presentation file "KI i forskning.pptx" with new content and enhancements.
</commit_message>
<xml_diff>
--- a/KI i forskning.pptx
+++ b/KI i forskning.pptx
@@ -5,23 +5,22 @@
     <p:sldMasterId id="2147483660" r:id="rId4"/>
   </p:sldMasterIdLst>
   <p:notesMasterIdLst>
-    <p:notesMasterId r:id="rId16"/>
+    <p:notesMasterId r:id="rId15"/>
   </p:notesMasterIdLst>
   <p:handoutMasterIdLst>
-    <p:handoutMasterId r:id="rId17"/>
+    <p:handoutMasterId r:id="rId16"/>
   </p:handoutMasterIdLst>
   <p:sldIdLst>
-    <p:sldId id="268" r:id="rId5"/>
-    <p:sldId id="272" r:id="rId6"/>
-    <p:sldId id="257" r:id="rId7"/>
-    <p:sldId id="258" r:id="rId8"/>
-    <p:sldId id="259" r:id="rId9"/>
-    <p:sldId id="260" r:id="rId10"/>
-    <p:sldId id="269" r:id="rId11"/>
-    <p:sldId id="263" r:id="rId12"/>
-    <p:sldId id="270" r:id="rId13"/>
-    <p:sldId id="271" r:id="rId14"/>
-    <p:sldId id="266" r:id="rId15"/>
+    <p:sldId id="272" r:id="rId5"/>
+    <p:sldId id="257" r:id="rId6"/>
+    <p:sldId id="258" r:id="rId7"/>
+    <p:sldId id="259" r:id="rId8"/>
+    <p:sldId id="260" r:id="rId9"/>
+    <p:sldId id="269" r:id="rId10"/>
+    <p:sldId id="263" r:id="rId11"/>
+    <p:sldId id="270" r:id="rId12"/>
+    <p:sldId id="271" r:id="rId13"/>
+    <p:sldId id="266" r:id="rId14"/>
   </p:sldIdLst>
   <p:sldSz cx="12192000" cy="6858000"/>
   <p:notesSz cx="6858000" cy="9144000"/>
@@ -231,7 +230,7 @@
           <a:p>
             <a:fld id="{12831F25-498C-4A0B-AD1F-EC339DC2833B}" type="datetimeFigureOut">
               <a:rPr lang="nb-NO" smtClean="0"/>
-              <a:t>24.04.2026</a:t>
+              <a:t>28.04.2026</a:t>
             </a:fld>
             <a:endParaRPr lang="nb-NO"/>
           </a:p>
@@ -408,7 +407,7 @@
           <a:p>
             <a:fld id="{AFEEBC5B-04F3-4C11-9453-AD70019F1296}" type="datetimeFigureOut">
               <a:rPr lang="nb-NO" smtClean="0"/>
-              <a:t>24.04.2026</a:t>
+              <a:t>28.04.2026</a:t>
             </a:fld>
             <a:endParaRPr lang="nb-NO"/>
           </a:p>
@@ -13250,246 +13249,6 @@
 </file>
 
 <file path=ppt/slideLayouts/slideLayout23.xml><?xml version="1.0" encoding="utf-8"?>
-<p:sldLayout xmlns:a="http://schemas.openxmlformats.org/drawingml/2006/main" xmlns:r="http://schemas.openxmlformats.org/officeDocument/2006/relationships" xmlns:p="http://schemas.openxmlformats.org/presentationml/2006/main" type="title">
-  <p:cSld name="Title Slide">
-    <p:spTree>
-      <p:nvGrpSpPr>
-        <p:cNvPr id="1" name=""/>
-        <p:cNvGrpSpPr/>
-        <p:nvPr/>
-      </p:nvGrpSpPr>
-      <p:grpSpPr>
-        <a:xfrm>
-          <a:off x="0" y="0"/>
-          <a:ext cx="0" cy="0"/>
-          <a:chOff x="0" y="0"/>
-          <a:chExt cx="0" cy="0"/>
-        </a:xfrm>
-      </p:grpSpPr>
-      <p:sp>
-        <p:nvSpPr>
-          <p:cNvPr id="2" name="Title 1"/>
-          <p:cNvSpPr>
-            <a:spLocks noGrp="1"/>
-          </p:cNvSpPr>
-          <p:nvPr>
-            <p:ph type="ctrTitle"/>
-          </p:nvPr>
-        </p:nvSpPr>
-        <p:spPr>
-          <a:xfrm>
-            <a:off x="914400" y="2130426"/>
-            <a:ext cx="10363200" cy="644151"/>
-          </a:xfrm>
-        </p:spPr>
-        <p:txBody>
-          <a:bodyPr/>
-          <a:lstStyle/>
-          <a:p>
-            <a:r>
-              <a:rPr lang="en-US"/>
-              <a:t>Click to edit Master title style</a:t>
-            </a:r>
-          </a:p>
-        </p:txBody>
-      </p:sp>
-      <p:sp>
-        <p:nvSpPr>
-          <p:cNvPr id="3" name="Subtitle 2"/>
-          <p:cNvSpPr>
-            <a:spLocks noGrp="1"/>
-          </p:cNvSpPr>
-          <p:nvPr>
-            <p:ph type="subTitle" idx="1"/>
-          </p:nvPr>
-        </p:nvSpPr>
-        <p:spPr>
-          <a:xfrm>
-            <a:off x="1828800" y="3886200"/>
-            <a:ext cx="8534400" cy="1752600"/>
-          </a:xfrm>
-        </p:spPr>
-        <p:txBody>
-          <a:bodyPr/>
-          <a:lstStyle>
-            <a:lvl1pPr marL="0" indent="0" algn="ctr">
-              <a:buNone/>
-              <a:defRPr>
-                <a:solidFill>
-                  <a:schemeClr val="tx1">
-                    <a:tint val="75000"/>
-                  </a:schemeClr>
-                </a:solidFill>
-              </a:defRPr>
-            </a:lvl1pPr>
-            <a:lvl2pPr marL="457189" indent="0" algn="ctr">
-              <a:buNone/>
-              <a:defRPr>
-                <a:solidFill>
-                  <a:schemeClr val="tx1">
-                    <a:tint val="75000"/>
-                  </a:schemeClr>
-                </a:solidFill>
-              </a:defRPr>
-            </a:lvl2pPr>
-            <a:lvl3pPr marL="914377" indent="0" algn="ctr">
-              <a:buNone/>
-              <a:defRPr>
-                <a:solidFill>
-                  <a:schemeClr val="tx1">
-                    <a:tint val="75000"/>
-                  </a:schemeClr>
-                </a:solidFill>
-              </a:defRPr>
-            </a:lvl3pPr>
-            <a:lvl4pPr marL="1371566" indent="0" algn="ctr">
-              <a:buNone/>
-              <a:defRPr>
-                <a:solidFill>
-                  <a:schemeClr val="tx1">
-                    <a:tint val="75000"/>
-                  </a:schemeClr>
-                </a:solidFill>
-              </a:defRPr>
-            </a:lvl4pPr>
-            <a:lvl5pPr marL="1828754" indent="0" algn="ctr">
-              <a:buNone/>
-              <a:defRPr>
-                <a:solidFill>
-                  <a:schemeClr val="tx1">
-                    <a:tint val="75000"/>
-                  </a:schemeClr>
-                </a:solidFill>
-              </a:defRPr>
-            </a:lvl5pPr>
-            <a:lvl6pPr marL="2285943" indent="0" algn="ctr">
-              <a:buNone/>
-              <a:defRPr>
-                <a:solidFill>
-                  <a:schemeClr val="tx1">
-                    <a:tint val="75000"/>
-                  </a:schemeClr>
-                </a:solidFill>
-              </a:defRPr>
-            </a:lvl6pPr>
-            <a:lvl7pPr marL="2743131" indent="0" algn="ctr">
-              <a:buNone/>
-              <a:defRPr>
-                <a:solidFill>
-                  <a:schemeClr val="tx1">
-                    <a:tint val="75000"/>
-                  </a:schemeClr>
-                </a:solidFill>
-              </a:defRPr>
-            </a:lvl7pPr>
-            <a:lvl8pPr marL="3200320" indent="0" algn="ctr">
-              <a:buNone/>
-              <a:defRPr>
-                <a:solidFill>
-                  <a:schemeClr val="tx1">
-                    <a:tint val="75000"/>
-                  </a:schemeClr>
-                </a:solidFill>
-              </a:defRPr>
-            </a:lvl8pPr>
-            <a:lvl9pPr marL="3657509" indent="0" algn="ctr">
-              <a:buNone/>
-              <a:defRPr>
-                <a:solidFill>
-                  <a:schemeClr val="tx1">
-                    <a:tint val="75000"/>
-                  </a:schemeClr>
-                </a:solidFill>
-              </a:defRPr>
-            </a:lvl9pPr>
-          </a:lstStyle>
-          <a:p>
-            <a:r>
-              <a:rPr lang="en-US"/>
-              <a:t>Click to edit Master subtitle style</a:t>
-            </a:r>
-          </a:p>
-        </p:txBody>
-      </p:sp>
-      <p:sp>
-        <p:nvSpPr>
-          <p:cNvPr id="4" name="Date Placeholder 3"/>
-          <p:cNvSpPr>
-            <a:spLocks noGrp="1"/>
-          </p:cNvSpPr>
-          <p:nvPr>
-            <p:ph type="dt" sz="half" idx="10"/>
-          </p:nvPr>
-        </p:nvSpPr>
-        <p:spPr/>
-        <p:txBody>
-          <a:bodyPr/>
-          <a:lstStyle/>
-          <a:p>
-            <a:fld id="{241EB5C9-1307-BA42-ABA2-0BC069CD8E7F}" type="datetimeFigureOut">
-              <a:rPr lang="en-US" smtClean="0"/>
-              <a:t>4/24/2026</a:t>
-            </a:fld>
-            <a:endParaRPr lang="en-US"/>
-          </a:p>
-        </p:txBody>
-      </p:sp>
-      <p:sp>
-        <p:nvSpPr>
-          <p:cNvPr id="5" name="Footer Placeholder 4"/>
-          <p:cNvSpPr>
-            <a:spLocks noGrp="1"/>
-          </p:cNvSpPr>
-          <p:nvPr>
-            <p:ph type="ftr" sz="quarter" idx="11"/>
-          </p:nvPr>
-        </p:nvSpPr>
-        <p:spPr/>
-        <p:txBody>
-          <a:bodyPr/>
-          <a:lstStyle/>
-          <a:p>
-            <a:endParaRPr lang="en-US"/>
-          </a:p>
-        </p:txBody>
-      </p:sp>
-      <p:sp>
-        <p:nvSpPr>
-          <p:cNvPr id="6" name="Slide Number Placeholder 5"/>
-          <p:cNvSpPr>
-            <a:spLocks noGrp="1"/>
-          </p:cNvSpPr>
-          <p:nvPr>
-            <p:ph type="sldNum" sz="quarter" idx="12"/>
-          </p:nvPr>
-        </p:nvSpPr>
-        <p:spPr/>
-        <p:txBody>
-          <a:bodyPr/>
-          <a:lstStyle/>
-          <a:p>
-            <a:fld id="{C5EF2332-01BF-834F-8236-50238282D533}" type="slidenum">
-              <a:rPr lang="en-US" smtClean="0"/>
-              <a:t>‹#›</a:t>
-            </a:fld>
-            <a:endParaRPr lang="en-US"/>
-          </a:p>
-        </p:txBody>
-      </p:sp>
-    </p:spTree>
-    <p:extLst>
-      <p:ext uri="{BB962C8B-B14F-4D97-AF65-F5344CB8AC3E}">
-        <p14:creationId xmlns:p14="http://schemas.microsoft.com/office/powerpoint/2010/main" val="4221158097"/>
-      </p:ext>
-    </p:extLst>
-  </p:cSld>
-  <p:clrMapOvr>
-    <a:masterClrMapping/>
-  </p:clrMapOvr>
-</p:sldLayout>
-</file>
-
-<file path=ppt/slideLayouts/slideLayout24.xml><?xml version="1.0" encoding="utf-8"?>
 <p:sldLayout xmlns:a="http://schemas.openxmlformats.org/drawingml/2006/main" xmlns:r="http://schemas.openxmlformats.org/officeDocument/2006/relationships" xmlns:p="http://schemas.openxmlformats.org/presentationml/2006/main" type="twoObj">
   <p:cSld name="Two Content">
     <p:spTree>
@@ -13713,7 +13472,7 @@
           <a:p>
             <a:fld id="{241EB5C9-1307-BA42-ABA2-0BC069CD8E7F}" type="datetimeFigureOut">
               <a:rPr lang="en-US" smtClean="0"/>
-              <a:t>4/24/2026</a:t>
+              <a:t>4/28/2026</a:t>
             </a:fld>
             <a:endParaRPr lang="en-US"/>
           </a:p>
@@ -13774,7 +13533,7 @@
 </p:sldLayout>
 </file>
 
-<file path=ppt/slideLayouts/slideLayout25.xml><?xml version="1.0" encoding="utf-8"?>
+<file path=ppt/slideLayouts/slideLayout24.xml><?xml version="1.0" encoding="utf-8"?>
 <p:sldLayout xmlns:a="http://schemas.openxmlformats.org/drawingml/2006/main" xmlns:r="http://schemas.openxmlformats.org/officeDocument/2006/relationships" xmlns:p="http://schemas.openxmlformats.org/presentationml/2006/main" type="obj">
   <p:cSld name="Title and Content">
     <p:spTree>
@@ -13881,7 +13640,7 @@
           <a:p>
             <a:fld id="{241EB5C9-1307-BA42-ABA2-0BC069CD8E7F}" type="datetimeFigureOut">
               <a:rPr lang="en-US" smtClean="0"/>
-              <a:t>4/24/2026</a:t>
+              <a:t>4/28/2026</a:t>
             </a:fld>
             <a:endParaRPr lang="en-US"/>
           </a:p>
@@ -15836,9 +15595,8 @@
     <p:sldLayoutId id="2147483923" r:id="rId20"/>
     <p:sldLayoutId id="2147483911" r:id="rId21"/>
     <p:sldLayoutId id="2147483921" r:id="rId22"/>
-    <p:sldLayoutId id="2147483928" r:id="rId23"/>
-    <p:sldLayoutId id="2147483929" r:id="rId24"/>
-    <p:sldLayoutId id="2147483930" r:id="rId25"/>
+    <p:sldLayoutId id="2147483929" r:id="rId23"/>
+    <p:sldLayoutId id="2147483930" r:id="rId24"/>
   </p:sldLayoutIdLst>
   <p:hf sldNum="0" hdr="0" ftr="0" dt="0"/>
   <p:txStyles>
@@ -16166,94 +15924,99 @@
       </p:grpSpPr>
       <p:sp>
         <p:nvSpPr>
-          <p:cNvPr id="2" name="Title 1"/>
+          <p:cNvPr id="2" name="Plassholder for tekst 1">
+            <a:extLst>
+              <a:ext uri="{FF2B5EF4-FFF2-40B4-BE49-F238E27FC236}">
+                <a16:creationId xmlns:a16="http://schemas.microsoft.com/office/drawing/2014/main" id="{6A8D9836-BB54-6215-65D7-168635F06BAA}"/>
+              </a:ext>
+            </a:extLst>
+          </p:cNvPr>
           <p:cNvSpPr>
             <a:spLocks noGrp="1"/>
           </p:cNvSpPr>
           <p:nvPr>
-            <p:ph type="ctrTitle"/>
+            <p:ph type="body" sz="quarter" idx="13"/>
+          </p:nvPr>
+        </p:nvSpPr>
+        <p:spPr/>
+        <p:txBody>
+          <a:bodyPr/>
+          <a:lstStyle/>
+          <a:p>
+            <a:r>
+              <a:rPr lang="nb-NO" dirty="0"/>
+              <a:t>28.04.2026</a:t>
+            </a:r>
+          </a:p>
+        </p:txBody>
+      </p:sp>
+      <p:sp>
+        <p:nvSpPr>
+          <p:cNvPr id="3" name="Plassholder for tekst 2">
+            <a:extLst>
+              <a:ext uri="{FF2B5EF4-FFF2-40B4-BE49-F238E27FC236}">
+                <a16:creationId xmlns:a16="http://schemas.microsoft.com/office/drawing/2014/main" id="{BD002637-85EF-D782-895E-21AEB3430253}"/>
+              </a:ext>
+            </a:extLst>
+          </p:cNvPr>
+          <p:cNvSpPr>
+            <a:spLocks noGrp="1"/>
+          </p:cNvSpPr>
+          <p:nvPr>
+            <p:ph type="body" sz="quarter" idx="14"/>
           </p:nvPr>
         </p:nvSpPr>
         <p:spPr>
           <a:xfrm>
-            <a:off x="914400" y="2130426"/>
-            <a:ext cx="10363200" cy="1288301"/>
+            <a:off x="1787632" y="1436404"/>
+            <a:ext cx="7807127" cy="2401042"/>
           </a:xfrm>
         </p:spPr>
         <p:txBody>
           <a:bodyPr/>
           <a:lstStyle/>
           <a:p>
-            <a:pPr algn="ctr"/>
-            <a:r>
-              <a:rPr dirty="0"/>
-              <a:t>KI </a:t>
-            </a:r>
-            <a:r>
-              <a:rPr dirty="0" err="1"/>
-              <a:t>i</a:t>
-            </a:r>
-            <a:r>
-              <a:rPr dirty="0"/>
-              <a:t> </a:t>
-            </a:r>
-            <a:r>
-              <a:rPr dirty="0" err="1"/>
-              <a:t>forskning</a:t>
-            </a:r>
-            <a:r>
-              <a:rPr dirty="0"/>
-              <a:t>: </a:t>
+            <a:r>
+              <a:rPr lang="nb-NO" dirty="0"/>
+              <a:t>KI i forskning: </a:t>
             </a:r>
             <a:br>
               <a:rPr lang="nb-NO" dirty="0"/>
             </a:br>
             <a:r>
-              <a:rPr dirty="0" err="1"/>
-              <a:t>Utnytte</a:t>
-            </a:r>
-            <a:r>
-              <a:rPr dirty="0"/>
-              <a:t> </a:t>
-            </a:r>
-            <a:r>
-              <a:rPr dirty="0" err="1"/>
-              <a:t>styrkene</a:t>
-            </a:r>
-            <a:r>
-              <a:rPr dirty="0"/>
-              <a:t>, </a:t>
-            </a:r>
-            <a:r>
-              <a:rPr dirty="0" err="1"/>
-              <a:t>kontrollere</a:t>
-            </a:r>
-            <a:r>
-              <a:rPr dirty="0"/>
-              <a:t> </a:t>
-            </a:r>
-            <a:r>
-              <a:rPr dirty="0" err="1"/>
-              <a:t>svakhetene</a:t>
-            </a:r>
-            <a:endParaRPr dirty="0"/>
+              <a:rPr lang="nb-NO" dirty="0"/>
+              <a:t>Utnytte styrkene, </a:t>
+            </a:r>
+            <a:br>
+              <a:rPr lang="nb-NO" dirty="0"/>
+            </a:br>
+            <a:r>
+              <a:rPr lang="nb-NO" dirty="0"/>
+              <a:t>kontrollere svakhetene</a:t>
+            </a:r>
           </a:p>
         </p:txBody>
       </p:sp>
       <p:sp>
         <p:nvSpPr>
-          <p:cNvPr id="3" name="Subtitle 2"/>
+          <p:cNvPr id="4" name="Plassholder for tekst 3">
+            <a:extLst>
+              <a:ext uri="{FF2B5EF4-FFF2-40B4-BE49-F238E27FC236}">
+                <a16:creationId xmlns:a16="http://schemas.microsoft.com/office/drawing/2014/main" id="{779647AA-8DFE-94AD-3775-9554D3465923}"/>
+              </a:ext>
+            </a:extLst>
+          </p:cNvPr>
           <p:cNvSpPr>
             <a:spLocks noGrp="1"/>
           </p:cNvSpPr>
           <p:nvPr>
-            <p:ph type="subTitle" idx="1"/>
+            <p:ph type="body" sz="quarter" idx="15"/>
           </p:nvPr>
         </p:nvSpPr>
         <p:spPr>
           <a:xfrm>
-            <a:off x="1828800" y="3886200"/>
-            <a:ext cx="8534400" cy="1752600"/>
+            <a:off x="1787633" y="4096793"/>
+            <a:ext cx="7807127" cy="415627"/>
           </a:xfrm>
         </p:spPr>
         <p:txBody>
@@ -16261,54 +16024,90 @@
           <a:lstStyle/>
           <a:p>
             <a:r>
-              <a:rPr dirty="0" err="1"/>
-              <a:t>Verktøy</a:t>
-            </a:r>
-            <a:r>
-              <a:rPr dirty="0"/>
-              <a:t> </a:t>
-            </a:r>
-            <a:r>
-              <a:rPr dirty="0" err="1"/>
-              <a:t>og</a:t>
-            </a:r>
-            <a:r>
-              <a:rPr dirty="0"/>
-              <a:t> </a:t>
-            </a:r>
-            <a:r>
-              <a:rPr dirty="0" err="1"/>
-              <a:t>teknikker</a:t>
-            </a:r>
-            <a:r>
-              <a:rPr dirty="0"/>
-              <a:t> for </a:t>
-            </a:r>
-            <a:r>
-              <a:rPr dirty="0" err="1"/>
-              <a:t>ansvarlig</a:t>
-            </a:r>
-            <a:r>
-              <a:rPr dirty="0"/>
-              <a:t> KI-bruk </a:t>
-            </a:r>
-            <a:r>
-              <a:rPr dirty="0" err="1"/>
-              <a:t>i</a:t>
-            </a:r>
-            <a:r>
-              <a:rPr dirty="0"/>
-              <a:t> </a:t>
-            </a:r>
-            <a:r>
-              <a:rPr dirty="0" err="1"/>
-              <a:t>forskning</a:t>
-            </a:r>
-            <a:endParaRPr dirty="0"/>
+              <a:rPr lang="nb-NO" dirty="0"/>
+              <a:t>Verktøy og teknikker for ansvarlig KI-bruk i forskning</a:t>
+            </a:r>
           </a:p>
         </p:txBody>
       </p:sp>
+      <p:pic>
+        <p:nvPicPr>
+          <p:cNvPr id="6" name="Bilde 5">
+            <a:extLst>
+              <a:ext uri="{FF2B5EF4-FFF2-40B4-BE49-F238E27FC236}">
+                <a16:creationId xmlns:a16="http://schemas.microsoft.com/office/drawing/2014/main" id="{B41377BF-E64A-CB57-AFF8-5D2D013FCD5E}"/>
+              </a:ext>
+            </a:extLst>
+          </p:cNvPr>
+          <p:cNvPicPr>
+            <a:picLocks noChangeAspect="1"/>
+          </p:cNvPicPr>
+          <p:nvPr/>
+        </p:nvPicPr>
+        <p:blipFill>
+          <a:blip r:embed="rId2">
+            <a:extLst>
+              <a:ext uri="{28A0092B-C50C-407E-A947-70E740481C1C}">
+                <a14:useLocalDpi xmlns:a14="http://schemas.microsoft.com/office/drawing/2010/main" val="0"/>
+              </a:ext>
+            </a:extLst>
+          </a:blip>
+          <a:stretch>
+            <a:fillRect/>
+          </a:stretch>
+        </p:blipFill>
+        <p:spPr>
+          <a:xfrm>
+            <a:off x="9970182" y="3988525"/>
+            <a:ext cx="2221818" cy="2866144"/>
+          </a:xfrm>
+          <a:prstGeom prst="rect">
+            <a:avLst/>
+          </a:prstGeom>
+        </p:spPr>
+      </p:pic>
+      <p:pic>
+        <p:nvPicPr>
+          <p:cNvPr id="8" name="Bilde 7">
+            <a:extLst>
+              <a:ext uri="{FF2B5EF4-FFF2-40B4-BE49-F238E27FC236}">
+                <a16:creationId xmlns:a16="http://schemas.microsoft.com/office/drawing/2014/main" id="{6EA29F5E-2471-A766-1689-CCE6F1BAC31F}"/>
+              </a:ext>
+            </a:extLst>
+          </p:cNvPr>
+          <p:cNvPicPr>
+            <a:picLocks noChangeAspect="1"/>
+          </p:cNvPicPr>
+          <p:nvPr/>
+        </p:nvPicPr>
+        <p:blipFill>
+          <a:blip r:embed="rId3">
+            <a:extLst>
+              <a:ext uri="{28A0092B-C50C-407E-A947-70E740481C1C}">
+                <a14:useLocalDpi xmlns:a14="http://schemas.microsoft.com/office/drawing/2010/main" val="0"/>
+              </a:ext>
+            </a:extLst>
+          </a:blip>
+          <a:stretch>
+            <a:fillRect/>
+          </a:stretch>
+        </p:blipFill>
+        <p:spPr>
+          <a:xfrm>
+            <a:off x="9970182" y="0"/>
+            <a:ext cx="2221818" cy="2866145"/>
+          </a:xfrm>
+          <a:prstGeom prst="rect">
+            <a:avLst/>
+          </a:prstGeom>
+        </p:spPr>
+      </p:pic>
     </p:spTree>
+    <p:extLst>
+      <p:ext uri="{BB962C8B-B14F-4D97-AF65-F5344CB8AC3E}">
+        <p14:creationId xmlns:p14="http://schemas.microsoft.com/office/powerpoint/2010/main" val="919253959"/>
+      </p:ext>
+    </p:extLst>
   </p:cSld>
   <p:clrMapOvr>
     <a:masterClrMapping/>
@@ -16333,6 +16132,80 @@
           <a:chExt cx="0" cy="0"/>
         </a:xfrm>
       </p:grpSpPr>
+      <p:pic>
+        <p:nvPicPr>
+          <p:cNvPr id="4" name="Bilde 3">
+            <a:extLst>
+              <a:ext uri="{FF2B5EF4-FFF2-40B4-BE49-F238E27FC236}">
+                <a16:creationId xmlns:a16="http://schemas.microsoft.com/office/drawing/2014/main" id="{00208CF0-D7C4-F515-3BDE-B2951336C184}"/>
+              </a:ext>
+            </a:extLst>
+          </p:cNvPr>
+          <p:cNvPicPr>
+            <a:picLocks noChangeAspect="1"/>
+          </p:cNvPicPr>
+          <p:nvPr/>
+        </p:nvPicPr>
+        <p:blipFill>
+          <a:blip r:embed="rId2">
+            <a:extLst>
+              <a:ext uri="{28A0092B-C50C-407E-A947-70E740481C1C}">
+                <a14:useLocalDpi xmlns:a14="http://schemas.microsoft.com/office/drawing/2010/main" val="0"/>
+              </a:ext>
+            </a:extLst>
+          </a:blip>
+          <a:srcRect b="15870"/>
+          <a:stretch>
+            <a:fillRect/>
+          </a:stretch>
+        </p:blipFill>
+        <p:spPr>
+          <a:xfrm>
+            <a:off x="9970182" y="4446727"/>
+            <a:ext cx="2221818" cy="2411273"/>
+          </a:xfrm>
+          <a:prstGeom prst="rect">
+            <a:avLst/>
+          </a:prstGeom>
+        </p:spPr>
+      </p:pic>
+      <p:pic>
+        <p:nvPicPr>
+          <p:cNvPr id="5" name="Bilde 4">
+            <a:extLst>
+              <a:ext uri="{FF2B5EF4-FFF2-40B4-BE49-F238E27FC236}">
+                <a16:creationId xmlns:a16="http://schemas.microsoft.com/office/drawing/2014/main" id="{9E3C1D8D-0200-3065-A2E0-870D1A5A2832}"/>
+              </a:ext>
+            </a:extLst>
+          </p:cNvPr>
+          <p:cNvPicPr>
+            <a:picLocks noChangeAspect="1"/>
+          </p:cNvPicPr>
+          <p:nvPr/>
+        </p:nvPicPr>
+        <p:blipFill>
+          <a:blip r:embed="rId3">
+            <a:extLst>
+              <a:ext uri="{28A0092B-C50C-407E-A947-70E740481C1C}">
+                <a14:useLocalDpi xmlns:a14="http://schemas.microsoft.com/office/drawing/2010/main" val="0"/>
+              </a:ext>
+            </a:extLst>
+          </a:blip>
+          <a:srcRect b="13973"/>
+          <a:stretch>
+            <a:fillRect/>
+          </a:stretch>
+        </p:blipFill>
+        <p:spPr>
+          <a:xfrm>
+            <a:off x="10053772" y="1"/>
+            <a:ext cx="2138228" cy="2372905"/>
+          </a:xfrm>
+          <a:prstGeom prst="rect">
+            <a:avLst/>
+          </a:prstGeom>
+        </p:spPr>
+      </p:pic>
       <p:sp>
         <p:nvSpPr>
           <p:cNvPr id="2" name="Title 1"/>
@@ -16349,403 +16222,10 @@
           <a:lstStyle/>
           <a:p>
             <a:r>
-              <a:t>Agentbaserte systemer</a:t>
-            </a:r>
-          </a:p>
-        </p:txBody>
-      </p:sp>
-      <p:sp>
-        <p:nvSpPr>
-          <p:cNvPr id="3" name="Content Placeholder 2"/>
-          <p:cNvSpPr>
-            <a:spLocks noGrp="1"/>
-          </p:cNvSpPr>
-          <p:nvPr>
-            <p:ph sz="half" idx="1"/>
-          </p:nvPr>
-        </p:nvSpPr>
-        <p:spPr>
-          <a:xfrm>
-            <a:off x="609599" y="1600201"/>
-            <a:ext cx="6304444" cy="4525963"/>
-          </a:xfrm>
-        </p:spPr>
-        <p:txBody>
-          <a:bodyPr>
-            <a:normAutofit lnSpcReduction="10000"/>
-          </a:bodyPr>
-          <a:lstStyle/>
-          <a:p>
-            <a:pPr lvl="0"/>
-            <a:r>
               <a:rPr dirty="0" err="1"/>
-              <a:t>Planlegger</a:t>
-            </a:r>
-            <a:r>
-              <a:rPr dirty="0"/>
-              <a:t> </a:t>
-            </a:r>
-            <a:r>
-              <a:rPr dirty="0" err="1"/>
-              <a:t>og</a:t>
-            </a:r>
-            <a:r>
-              <a:rPr dirty="0"/>
-              <a:t> </a:t>
-            </a:r>
-            <a:r>
-              <a:rPr dirty="0" err="1"/>
-              <a:t>gjennomfører</a:t>
-            </a:r>
-            <a:r>
-              <a:rPr dirty="0"/>
-              <a:t> </a:t>
-            </a:r>
-            <a:r>
-              <a:rPr dirty="0" err="1"/>
-              <a:t>flertrinnsoppgaver</a:t>
-            </a:r>
-            <a:r>
-              <a:rPr dirty="0"/>
-              <a:t> med minimal input.</a:t>
-            </a:r>
-          </a:p>
-          <a:p>
-            <a:pPr lvl="0"/>
-            <a:r>
-              <a:rPr dirty="0"/>
-              <a:t>Kan </a:t>
-            </a:r>
-            <a:r>
-              <a:rPr dirty="0" err="1"/>
-              <a:t>bruke</a:t>
-            </a:r>
-            <a:r>
-              <a:rPr dirty="0"/>
-              <a:t> </a:t>
-            </a:r>
-            <a:r>
-              <a:rPr dirty="0" err="1"/>
-              <a:t>eksterne</a:t>
-            </a:r>
-            <a:r>
-              <a:rPr dirty="0"/>
-              <a:t> </a:t>
-            </a:r>
-            <a:r>
-              <a:rPr dirty="0" err="1"/>
-              <a:t>verktøy</a:t>
-            </a:r>
-            <a:r>
-              <a:rPr dirty="0"/>
-              <a:t>: </a:t>
-            </a:r>
-            <a:r>
-              <a:rPr dirty="0" err="1"/>
-              <a:t>nettsøk</a:t>
-            </a:r>
-            <a:r>
-              <a:rPr dirty="0"/>
-              <a:t>, </a:t>
-            </a:r>
-            <a:r>
-              <a:rPr dirty="0" err="1"/>
-              <a:t>filsystem</a:t>
-            </a:r>
-            <a:r>
-              <a:rPr dirty="0"/>
-              <a:t>, </a:t>
-            </a:r>
-            <a:r>
-              <a:rPr dirty="0" err="1"/>
-              <a:t>databaser</a:t>
-            </a:r>
-            <a:r>
-              <a:rPr dirty="0"/>
-              <a:t> </a:t>
-            </a:r>
-            <a:r>
-              <a:rPr dirty="0" err="1"/>
-              <a:t>og</a:t>
-            </a:r>
-            <a:r>
-              <a:rPr dirty="0"/>
-              <a:t> API-er.</a:t>
-            </a:r>
-          </a:p>
-          <a:p>
-            <a:pPr lvl="0"/>
-            <a:r>
-              <a:rPr b="1" dirty="0"/>
-              <a:t>Skriver </a:t>
-            </a:r>
-            <a:r>
-              <a:rPr b="1" dirty="0" err="1"/>
-              <a:t>og</a:t>
-            </a:r>
-            <a:r>
-              <a:rPr b="1" dirty="0"/>
-              <a:t> </a:t>
-            </a:r>
-            <a:r>
-              <a:rPr b="1" dirty="0" err="1"/>
-              <a:t>kjører</a:t>
-            </a:r>
-            <a:r>
-              <a:rPr b="1" dirty="0"/>
-              <a:t> </a:t>
-            </a:r>
-            <a:r>
-              <a:rPr b="1" dirty="0" err="1"/>
-              <a:t>kode</a:t>
-            </a:r>
-            <a:r>
-              <a:rPr b="1" dirty="0"/>
-              <a:t>.</a:t>
-            </a:r>
-          </a:p>
-          <a:p>
-            <a:pPr lvl="0"/>
-            <a:r>
-              <a:rPr dirty="0"/>
-              <a:t>Arbeider </a:t>
-            </a:r>
-            <a:r>
-              <a:rPr dirty="0" err="1"/>
-              <a:t>iterativt</a:t>
-            </a:r>
-            <a:r>
-              <a:rPr dirty="0"/>
-              <a:t> — </a:t>
-            </a:r>
-            <a:r>
-              <a:rPr dirty="0" err="1"/>
-              <a:t>kjører</a:t>
-            </a:r>
-            <a:r>
-              <a:rPr dirty="0"/>
-              <a:t> </a:t>
-            </a:r>
-            <a:r>
-              <a:rPr dirty="0" err="1"/>
-              <a:t>kode</a:t>
-            </a:r>
-            <a:r>
-              <a:rPr dirty="0"/>
-              <a:t>, </a:t>
-            </a:r>
-            <a:r>
-              <a:rPr dirty="0" err="1"/>
-              <a:t>leser</a:t>
-            </a:r>
-            <a:r>
-              <a:rPr dirty="0"/>
-              <a:t> </a:t>
-            </a:r>
-            <a:r>
-              <a:rPr dirty="0" err="1"/>
-              <a:t>feil</a:t>
-            </a:r>
-            <a:r>
-              <a:rPr dirty="0"/>
-              <a:t> </a:t>
-            </a:r>
-            <a:r>
-              <a:rPr dirty="0" err="1"/>
-              <a:t>og</a:t>
-            </a:r>
-            <a:r>
-              <a:rPr dirty="0"/>
-              <a:t> </a:t>
-            </a:r>
-            <a:r>
-              <a:rPr b="1" dirty="0" err="1"/>
-              <a:t>korrigerer</a:t>
-            </a:r>
-            <a:r>
-              <a:rPr b="1" dirty="0"/>
-              <a:t> seg </a:t>
-            </a:r>
-            <a:r>
-              <a:rPr b="1" dirty="0" err="1"/>
-              <a:t>selv</a:t>
-            </a:r>
-            <a:r>
-              <a:rPr dirty="0"/>
-              <a:t>.</a:t>
-            </a:r>
-          </a:p>
-          <a:p>
-            <a:pPr lvl="0"/>
-            <a:r>
-              <a:rPr dirty="0"/>
-              <a:t>Mest </a:t>
-            </a:r>
-            <a:r>
-              <a:rPr dirty="0" err="1"/>
-              <a:t>effektivt</a:t>
-            </a:r>
-            <a:r>
-              <a:rPr dirty="0"/>
-              <a:t> </a:t>
-            </a:r>
-            <a:r>
-              <a:rPr dirty="0" err="1"/>
-              <a:t>når</a:t>
-            </a:r>
-            <a:r>
-              <a:rPr dirty="0"/>
-              <a:t> du </a:t>
-            </a:r>
-            <a:r>
-              <a:rPr dirty="0" err="1"/>
-              <a:t>kan</a:t>
-            </a:r>
-            <a:r>
-              <a:rPr dirty="0"/>
-              <a:t> </a:t>
-            </a:r>
-            <a:r>
-              <a:rPr dirty="0" err="1"/>
-              <a:t>vurdere</a:t>
-            </a:r>
-            <a:r>
-              <a:rPr dirty="0"/>
-              <a:t> om </a:t>
-            </a:r>
-            <a:r>
-              <a:rPr dirty="0" err="1"/>
-              <a:t>resultatet</a:t>
-            </a:r>
-            <a:r>
-              <a:rPr dirty="0"/>
-              <a:t> er </a:t>
-            </a:r>
-            <a:r>
-              <a:rPr dirty="0" err="1"/>
-              <a:t>korrekt</a:t>
-            </a:r>
-            <a:r>
-              <a:rPr dirty="0"/>
-              <a:t>.</a:t>
-            </a:r>
-          </a:p>
-        </p:txBody>
-      </p:sp>
-      <p:sp>
-        <p:nvSpPr>
-          <p:cNvPr id="4" name="Content Placeholder 3"/>
-          <p:cNvSpPr>
-            <a:spLocks noGrp="1"/>
-          </p:cNvSpPr>
-          <p:nvPr>
-            <p:ph sz="half" idx="2"/>
-          </p:nvPr>
-        </p:nvSpPr>
-        <p:spPr>
-          <a:xfrm>
-            <a:off x="7026443" y="1600202"/>
-            <a:ext cx="4555958" cy="2249904"/>
-          </a:xfrm>
-        </p:spPr>
-        <p:txBody>
-          <a:bodyPr>
-            <a:normAutofit lnSpcReduction="10000"/>
-          </a:bodyPr>
-          <a:lstStyle/>
-          <a:p>
-            <a:pPr lvl="0"/>
-            <a:r>
-              <a:rPr sz="1867" dirty="0"/>
-              <a:t>cursor.com</a:t>
-            </a:r>
-          </a:p>
-          <a:p>
-            <a:pPr lvl="0"/>
-            <a:r>
-              <a:rPr sz="1867" dirty="0"/>
-              <a:t>anthropic.com/product/</a:t>
-            </a:r>
-            <a:r>
-              <a:rPr sz="1867" dirty="0" err="1"/>
-              <a:t>claude</a:t>
-            </a:r>
-            <a:r>
-              <a:rPr sz="1867" dirty="0"/>
-              <a:t>-code</a:t>
-            </a:r>
-          </a:p>
-          <a:p>
-            <a:pPr lvl="0"/>
-            <a:r>
-              <a:rPr sz="1867" dirty="0"/>
-              <a:t>anthropic.com/product/</a:t>
-            </a:r>
-            <a:r>
-              <a:rPr sz="1867" dirty="0" err="1"/>
-              <a:t>claude-cowork</a:t>
-            </a:r>
-            <a:endParaRPr sz="1867" dirty="0"/>
-          </a:p>
-          <a:p>
-            <a:pPr lvl="0"/>
-            <a:r>
-              <a:rPr sz="1867" dirty="0"/>
-              <a:t>https://antigravity.google/</a:t>
-            </a:r>
-          </a:p>
-          <a:p>
-            <a:pPr lvl="0"/>
-            <a:r>
-              <a:rPr sz="1867" dirty="0"/>
-              <a:t>…</a:t>
-            </a:r>
-          </a:p>
-        </p:txBody>
-      </p:sp>
-    </p:spTree>
-  </p:cSld>
-  <p:clrMapOvr>
-    <a:masterClrMapping/>
-  </p:clrMapOvr>
-</p:sld>
-</file>
-
-<file path=ppt/slides/slide11.xml><?xml version="1.0" encoding="utf-8"?>
-<p:sld xmlns:a="http://schemas.openxmlformats.org/drawingml/2006/main" xmlns:r="http://schemas.openxmlformats.org/officeDocument/2006/relationships" xmlns:p="http://schemas.openxmlformats.org/presentationml/2006/main">
-  <p:cSld>
-    <p:spTree>
-      <p:nvGrpSpPr>
-        <p:cNvPr id="1" name=""/>
-        <p:cNvGrpSpPr/>
-        <p:nvPr/>
-      </p:nvGrpSpPr>
-      <p:grpSpPr>
-        <a:xfrm>
-          <a:off x="0" y="0"/>
-          <a:ext cx="0" cy="0"/>
-          <a:chOff x="0" y="0"/>
-          <a:chExt cx="0" cy="0"/>
-        </a:xfrm>
-      </p:grpSpPr>
-      <p:sp>
-        <p:nvSpPr>
-          <p:cNvPr id="2" name="Title 1"/>
-          <p:cNvSpPr>
-            <a:spLocks noGrp="1"/>
-          </p:cNvSpPr>
-          <p:nvPr>
-            <p:ph type="title"/>
-          </p:nvPr>
-        </p:nvSpPr>
-        <p:spPr/>
-        <p:txBody>
-          <a:bodyPr/>
-          <a:lstStyle/>
-          <a:p>
-            <a:r>
               <a:t>Oppsummering</a:t>
             </a:r>
+            <a:endParaRPr dirty="0"/>
           </a:p>
         </p:txBody>
       </p:sp>
@@ -16762,12 +16242,12 @@
         <p:spPr>
           <a:xfrm>
             <a:off x="1015459" y="1796716"/>
-            <a:ext cx="10515600" cy="4113278"/>
+            <a:ext cx="10063139" cy="4732553"/>
           </a:xfrm>
         </p:spPr>
         <p:txBody>
           <a:bodyPr>
-            <a:normAutofit fontScale="92500"/>
+            <a:normAutofit lnSpcReduction="10000"/>
           </a:bodyPr>
           <a:lstStyle/>
           <a:p>
@@ -16995,7 +16475,17 @@
             </a:r>
             <a:r>
               <a:rPr b="1" dirty="0"/>
-              <a:t>. KI-</a:t>
+              <a:t>. </a:t>
+            </a:r>
+            <a:endParaRPr lang="nb-NO" b="1" dirty="0"/>
+          </a:p>
+          <a:p>
+            <a:pPr marL="0" indent="0">
+              <a:buNone/>
+            </a:pPr>
+            <a:r>
+              <a:rPr b="1" dirty="0"/>
+              <a:t>KI-</a:t>
             </a:r>
             <a:r>
               <a:rPr b="1" dirty="0" err="1"/>
@@ -17019,7 +16509,17 @@
             </a:r>
             <a:r>
               <a:rPr b="1" dirty="0"/>
-              <a:t>. Det vi </a:t>
+              <a:t>. </a:t>
+            </a:r>
+            <a:endParaRPr lang="nb-NO" b="1" dirty="0"/>
+          </a:p>
+          <a:p>
+            <a:pPr marL="0" indent="0">
+              <a:buNone/>
+            </a:pPr>
+            <a:r>
+              <a:rPr b="1" dirty="0"/>
+              <a:t>Det vi </a:t>
             </a:r>
             <a:r>
               <a:rPr b="1" dirty="0" err="1"/>
@@ -17073,144 +16573,6 @@
 </file>
 
 <file path=ppt/slides/slide2.xml><?xml version="1.0" encoding="utf-8"?>
-<p:sld xmlns:a="http://schemas.openxmlformats.org/drawingml/2006/main" xmlns:r="http://schemas.openxmlformats.org/officeDocument/2006/relationships" xmlns:p="http://schemas.openxmlformats.org/presentationml/2006/main">
-  <p:cSld>
-    <p:spTree>
-      <p:nvGrpSpPr>
-        <p:cNvPr id="1" name=""/>
-        <p:cNvGrpSpPr/>
-        <p:nvPr/>
-      </p:nvGrpSpPr>
-      <p:grpSpPr>
-        <a:xfrm>
-          <a:off x="0" y="0"/>
-          <a:ext cx="0" cy="0"/>
-          <a:chOff x="0" y="0"/>
-          <a:chExt cx="0" cy="0"/>
-        </a:xfrm>
-      </p:grpSpPr>
-      <p:sp>
-        <p:nvSpPr>
-          <p:cNvPr id="2" name="Plassholder for tekst 1">
-            <a:extLst>
-              <a:ext uri="{FF2B5EF4-FFF2-40B4-BE49-F238E27FC236}">
-                <a16:creationId xmlns:a16="http://schemas.microsoft.com/office/drawing/2014/main" id="{6A8D9836-BB54-6215-65D7-168635F06BAA}"/>
-              </a:ext>
-            </a:extLst>
-          </p:cNvPr>
-          <p:cNvSpPr>
-            <a:spLocks noGrp="1"/>
-          </p:cNvSpPr>
-          <p:nvPr>
-            <p:ph type="body" sz="quarter" idx="13"/>
-          </p:nvPr>
-        </p:nvSpPr>
-        <p:spPr/>
-        <p:txBody>
-          <a:bodyPr/>
-          <a:lstStyle/>
-          <a:p>
-            <a:r>
-              <a:rPr lang="nb-NO" dirty="0"/>
-              <a:t>28.04.2026</a:t>
-            </a:r>
-          </a:p>
-        </p:txBody>
-      </p:sp>
-      <p:sp>
-        <p:nvSpPr>
-          <p:cNvPr id="3" name="Plassholder for tekst 2">
-            <a:extLst>
-              <a:ext uri="{FF2B5EF4-FFF2-40B4-BE49-F238E27FC236}">
-                <a16:creationId xmlns:a16="http://schemas.microsoft.com/office/drawing/2014/main" id="{BD002637-85EF-D782-895E-21AEB3430253}"/>
-              </a:ext>
-            </a:extLst>
-          </p:cNvPr>
-          <p:cNvSpPr>
-            <a:spLocks noGrp="1"/>
-          </p:cNvSpPr>
-          <p:nvPr>
-            <p:ph type="body" sz="quarter" idx="14"/>
-          </p:nvPr>
-        </p:nvSpPr>
-        <p:spPr>
-          <a:xfrm>
-            <a:off x="1787632" y="1436404"/>
-            <a:ext cx="7807127" cy="2401042"/>
-          </a:xfrm>
-        </p:spPr>
-        <p:txBody>
-          <a:bodyPr/>
-          <a:lstStyle/>
-          <a:p>
-            <a:r>
-              <a:rPr lang="nb-NO" dirty="0"/>
-              <a:t>KI i forskning: </a:t>
-            </a:r>
-            <a:br>
-              <a:rPr lang="nb-NO" dirty="0"/>
-            </a:br>
-            <a:r>
-              <a:rPr lang="nb-NO" dirty="0"/>
-              <a:t>Utnytte styrkene, </a:t>
-            </a:r>
-            <a:br>
-              <a:rPr lang="nb-NO" dirty="0"/>
-            </a:br>
-            <a:r>
-              <a:rPr lang="nb-NO" dirty="0"/>
-              <a:t>kontrollere svakhetene</a:t>
-            </a:r>
-          </a:p>
-        </p:txBody>
-      </p:sp>
-      <p:sp>
-        <p:nvSpPr>
-          <p:cNvPr id="4" name="Plassholder for tekst 3">
-            <a:extLst>
-              <a:ext uri="{FF2B5EF4-FFF2-40B4-BE49-F238E27FC236}">
-                <a16:creationId xmlns:a16="http://schemas.microsoft.com/office/drawing/2014/main" id="{779647AA-8DFE-94AD-3775-9554D3465923}"/>
-              </a:ext>
-            </a:extLst>
-          </p:cNvPr>
-          <p:cNvSpPr>
-            <a:spLocks noGrp="1"/>
-          </p:cNvSpPr>
-          <p:nvPr>
-            <p:ph type="body" sz="quarter" idx="15"/>
-          </p:nvPr>
-        </p:nvSpPr>
-        <p:spPr>
-          <a:xfrm>
-            <a:off x="1787633" y="4096793"/>
-            <a:ext cx="7807127" cy="415627"/>
-          </a:xfrm>
-        </p:spPr>
-        <p:txBody>
-          <a:bodyPr/>
-          <a:lstStyle/>
-          <a:p>
-            <a:r>
-              <a:rPr lang="nb-NO" dirty="0"/>
-              <a:t>Verktøy og teknikker for ansvarlig KI-bruk i forskning</a:t>
-            </a:r>
-          </a:p>
-        </p:txBody>
-      </p:sp>
-    </p:spTree>
-    <p:extLst>
-      <p:ext uri="{BB962C8B-B14F-4D97-AF65-F5344CB8AC3E}">
-        <p14:creationId xmlns:p14="http://schemas.microsoft.com/office/powerpoint/2010/main" val="919253959"/>
-      </p:ext>
-    </p:extLst>
-  </p:cSld>
-  <p:clrMapOvr>
-    <a:masterClrMapping/>
-  </p:clrMapOvr>
-</p:sld>
-</file>
-
-<file path=ppt/slides/slide3.xml><?xml version="1.0" encoding="utf-8"?>
 <p:sld xmlns:a="http://schemas.openxmlformats.org/drawingml/2006/main" xmlns:r="http://schemas.openxmlformats.org/officeDocument/2006/relationships" xmlns:p="http://schemas.openxmlformats.org/presentationml/2006/main">
   <p:cSld>
     <p:spTree>
@@ -17257,7 +16619,7 @@
             </a:r>
             <a:r>
               <a:rPr lang="nb-NO" dirty="0"/>
-              <a:t> «forsking»</a:t>
+              <a:t> «forskning»</a:t>
             </a:r>
             <a:endParaRPr dirty="0"/>
           </a:p>
@@ -17471,6 +16833,412 @@
 </p:sld>
 </file>
 
+<file path=ppt/slides/slide3.xml><?xml version="1.0" encoding="utf-8"?>
+<p:sld xmlns:a="http://schemas.openxmlformats.org/drawingml/2006/main" xmlns:r="http://schemas.openxmlformats.org/officeDocument/2006/relationships" xmlns:p="http://schemas.openxmlformats.org/presentationml/2006/main">
+  <p:cSld>
+    <p:spTree>
+      <p:nvGrpSpPr>
+        <p:cNvPr id="1" name=""/>
+        <p:cNvGrpSpPr/>
+        <p:nvPr/>
+      </p:nvGrpSpPr>
+      <p:grpSpPr>
+        <a:xfrm>
+          <a:off x="0" y="0"/>
+          <a:ext cx="0" cy="0"/>
+          <a:chOff x="0" y="0"/>
+          <a:chExt cx="0" cy="0"/>
+        </a:xfrm>
+      </p:grpSpPr>
+      <p:sp>
+        <p:nvSpPr>
+          <p:cNvPr id="2" name="Title 1"/>
+          <p:cNvSpPr>
+            <a:spLocks noGrp="1"/>
+          </p:cNvSpPr>
+          <p:nvPr>
+            <p:ph type="title"/>
+          </p:nvPr>
+        </p:nvSpPr>
+        <p:spPr/>
+        <p:txBody>
+          <a:bodyPr/>
+          <a:lstStyle/>
+          <a:p>
+            <a:r>
+              <a:t>LLM-problemer for forskere</a:t>
+            </a:r>
+          </a:p>
+        </p:txBody>
+      </p:sp>
+      <p:sp>
+        <p:nvSpPr>
+          <p:cNvPr id="3" name="Content Placeholder 2"/>
+          <p:cNvSpPr>
+            <a:spLocks noGrp="1"/>
+          </p:cNvSpPr>
+          <p:nvPr>
+            <p:ph idx="1"/>
+          </p:nvPr>
+        </p:nvSpPr>
+        <p:spPr>
+          <a:xfrm>
+            <a:off x="1015459" y="2177396"/>
+            <a:ext cx="10515600" cy="4191320"/>
+          </a:xfrm>
+        </p:spPr>
+        <p:txBody>
+          <a:bodyPr>
+            <a:normAutofit fontScale="92500"/>
+          </a:bodyPr>
+          <a:lstStyle/>
+          <a:p>
+            <a:pPr lvl="0"/>
+            <a:r>
+              <a:rPr dirty="0"/>
+              <a:t>LLM-er er </a:t>
+            </a:r>
+            <a:r>
+              <a:rPr b="1" dirty="0" err="1"/>
+              <a:t>prediksjons</a:t>
+            </a:r>
+            <a:r>
+              <a:rPr b="1" dirty="0"/>
+              <a:t>-/</a:t>
+            </a:r>
+            <a:r>
+              <a:rPr b="1" dirty="0" err="1"/>
+              <a:t>interpolasjonsmaskiner</a:t>
+            </a:r>
+            <a:r>
+              <a:rPr dirty="0"/>
+              <a:t>: De </a:t>
+            </a:r>
+            <a:r>
+              <a:rPr dirty="0" err="1"/>
+              <a:t>modellerer</a:t>
+            </a:r>
+            <a:r>
+              <a:rPr dirty="0"/>
+              <a:t> den </a:t>
+            </a:r>
+            <a:r>
+              <a:rPr dirty="0" err="1"/>
+              <a:t>temporale</a:t>
+            </a:r>
+            <a:r>
+              <a:rPr dirty="0"/>
+              <a:t> </a:t>
+            </a:r>
+            <a:r>
+              <a:rPr dirty="0" err="1"/>
+              <a:t>rekkefølgen</a:t>
+            </a:r>
+            <a:r>
+              <a:rPr dirty="0"/>
+              <a:t> </a:t>
+            </a:r>
+            <a:r>
+              <a:rPr dirty="0" err="1"/>
+              <a:t>til</a:t>
+            </a:r>
+            <a:r>
+              <a:rPr dirty="0"/>
+              <a:t> tokens (</a:t>
+            </a:r>
+            <a:r>
+              <a:rPr dirty="0" err="1"/>
+              <a:t>ord</a:t>
+            </a:r>
+            <a:r>
+              <a:rPr lang="nb-NO" dirty="0"/>
+              <a:t>eler</a:t>
+            </a:r>
+            <a:r>
+              <a:rPr dirty="0"/>
+              <a:t>)</a:t>
+            </a:r>
+          </a:p>
+          <a:p>
+            <a:pPr lvl="0"/>
+            <a:r>
+              <a:rPr dirty="0"/>
+              <a:t>Dette er </a:t>
+            </a:r>
+            <a:r>
+              <a:rPr b="1" dirty="0" err="1"/>
+              <a:t>svært</a:t>
+            </a:r>
+            <a:r>
+              <a:rPr b="1" dirty="0"/>
+              <a:t> </a:t>
+            </a:r>
+            <a:r>
+              <a:rPr b="1" dirty="0" err="1"/>
+              <a:t>nyttig</a:t>
+            </a:r>
+            <a:r>
+              <a:rPr dirty="0"/>
+              <a:t>, </a:t>
+            </a:r>
+            <a:r>
+              <a:rPr dirty="0" err="1"/>
+              <a:t>fordi</a:t>
+            </a:r>
+            <a:r>
+              <a:rPr dirty="0"/>
+              <a:t> </a:t>
+            </a:r>
+            <a:r>
+              <a:rPr dirty="0" err="1"/>
+              <a:t>riktig</a:t>
+            </a:r>
+            <a:r>
+              <a:rPr dirty="0"/>
+              <a:t> </a:t>
+            </a:r>
+            <a:r>
+              <a:rPr dirty="0" err="1"/>
+              <a:t>ordnede</a:t>
+            </a:r>
+            <a:r>
+              <a:rPr dirty="0"/>
+              <a:t> </a:t>
+            </a:r>
+            <a:r>
+              <a:rPr dirty="0" err="1"/>
+              <a:t>ord</a:t>
+            </a:r>
+            <a:r>
+              <a:rPr dirty="0"/>
+              <a:t> </a:t>
+            </a:r>
+            <a:r>
+              <a:rPr dirty="0" err="1"/>
+              <a:t>faktisk</a:t>
+            </a:r>
+            <a:r>
+              <a:rPr dirty="0"/>
+              <a:t> </a:t>
+            </a:r>
+            <a:r>
+              <a:rPr dirty="0" err="1"/>
+              <a:t>inneholder</a:t>
+            </a:r>
+            <a:r>
+              <a:rPr dirty="0"/>
+              <a:t> </a:t>
+            </a:r>
+            <a:r>
+              <a:rPr dirty="0" err="1"/>
+              <a:t>mening</a:t>
+            </a:r>
+            <a:endParaRPr dirty="0"/>
+          </a:p>
+          <a:p>
+            <a:pPr lvl="0"/>
+            <a:r>
+              <a:rPr dirty="0"/>
+              <a:t>Men </a:t>
+            </a:r>
+            <a:r>
+              <a:rPr dirty="0" err="1"/>
+              <a:t>måten</a:t>
+            </a:r>
+            <a:r>
+              <a:rPr dirty="0"/>
+              <a:t> LLM-er er </a:t>
+            </a:r>
+            <a:r>
+              <a:rPr dirty="0" err="1"/>
+              <a:t>bygget</a:t>
+            </a:r>
+            <a:r>
+              <a:rPr dirty="0"/>
+              <a:t> </a:t>
+            </a:r>
+            <a:r>
+              <a:rPr dirty="0" err="1"/>
+              <a:t>på</a:t>
+            </a:r>
+            <a:r>
+              <a:rPr dirty="0"/>
+              <a:t> </a:t>
+            </a:r>
+            <a:r>
+              <a:rPr dirty="0" err="1"/>
+              <a:t>skaper</a:t>
+            </a:r>
+            <a:r>
+              <a:rPr dirty="0"/>
+              <a:t> 2 </a:t>
+            </a:r>
+            <a:r>
+              <a:rPr dirty="0" err="1"/>
+              <a:t>problemer</a:t>
+            </a:r>
+            <a:r>
+              <a:rPr dirty="0"/>
+              <a:t> for </a:t>
+            </a:r>
+            <a:r>
+              <a:rPr dirty="0" err="1"/>
+              <a:t>forskere</a:t>
+            </a:r>
+            <a:r>
+              <a:rPr dirty="0"/>
+              <a:t> </a:t>
+            </a:r>
+            <a:r>
+              <a:rPr dirty="0" err="1"/>
+              <a:t>når</a:t>
+            </a:r>
+            <a:r>
+              <a:rPr dirty="0"/>
+              <a:t> «nye» </a:t>
+            </a:r>
+            <a:r>
+              <a:rPr dirty="0" err="1"/>
+              <a:t>ordrekker</a:t>
+            </a:r>
+            <a:r>
+              <a:rPr dirty="0"/>
+              <a:t> </a:t>
+            </a:r>
+            <a:r>
+              <a:rPr dirty="0" err="1"/>
+              <a:t>genereres</a:t>
+            </a:r>
+            <a:endParaRPr dirty="0"/>
+          </a:p>
+          <a:p>
+            <a:pPr lvl="1"/>
+            <a:r>
+              <a:rPr b="1" dirty="0" err="1"/>
+              <a:t>Regresjon</a:t>
+            </a:r>
+            <a:r>
+              <a:rPr b="1" dirty="0"/>
+              <a:t> mot </a:t>
+            </a:r>
+            <a:r>
+              <a:rPr b="1" dirty="0" err="1"/>
+              <a:t>modalverdien</a:t>
+            </a:r>
+            <a:r>
+              <a:rPr dirty="0"/>
+              <a:t> </a:t>
+            </a:r>
+            <a:r>
+              <a:rPr dirty="0" err="1"/>
+              <a:t>i</a:t>
+            </a:r>
+            <a:r>
+              <a:rPr dirty="0"/>
+              <a:t> </a:t>
+            </a:r>
+            <a:r>
+              <a:rPr dirty="0" err="1"/>
+              <a:t>treningsdataene</a:t>
+            </a:r>
+            <a:endParaRPr dirty="0"/>
+          </a:p>
+          <a:p>
+            <a:pPr lvl="1"/>
+            <a:r>
+              <a:rPr b="1" dirty="0" err="1"/>
+              <a:t>Hallusinasjon</a:t>
+            </a:r>
+            <a:endParaRPr b="1" dirty="0"/>
+          </a:p>
+          <a:p>
+            <a:pPr marL="0" indent="0">
+              <a:buNone/>
+            </a:pPr>
+            <a:r>
+              <a:rPr dirty="0"/>
+              <a:t>Som </a:t>
+            </a:r>
+            <a:r>
+              <a:rPr dirty="0" err="1"/>
+              <a:t>forskere</a:t>
+            </a:r>
+            <a:r>
+              <a:rPr dirty="0"/>
+              <a:t> </a:t>
+            </a:r>
+            <a:r>
+              <a:rPr dirty="0" err="1"/>
+              <a:t>ønsker</a:t>
+            </a:r>
+            <a:r>
+              <a:rPr dirty="0"/>
+              <a:t> vi å </a:t>
+            </a:r>
+            <a:r>
+              <a:rPr dirty="0" err="1"/>
+              <a:t>utnytte</a:t>
+            </a:r>
+            <a:r>
+              <a:rPr dirty="0"/>
+              <a:t> </a:t>
+            </a:r>
+            <a:r>
+              <a:rPr dirty="0" err="1"/>
+              <a:t>nytten</a:t>
+            </a:r>
+            <a:r>
+              <a:rPr dirty="0"/>
+              <a:t> av LLM-er </a:t>
+            </a:r>
+            <a:r>
+              <a:rPr dirty="0" err="1"/>
+              <a:t>samtidig</a:t>
+            </a:r>
+            <a:r>
+              <a:rPr dirty="0"/>
+              <a:t> </a:t>
+            </a:r>
+            <a:r>
+              <a:rPr dirty="0" err="1"/>
+              <a:t>som</a:t>
+            </a:r>
+            <a:r>
+              <a:rPr dirty="0"/>
+              <a:t> vi </a:t>
+            </a:r>
+            <a:r>
+              <a:rPr dirty="0" err="1"/>
+              <a:t>kontrollerer</a:t>
+            </a:r>
+            <a:r>
+              <a:rPr dirty="0"/>
+              <a:t> </a:t>
+            </a:r>
+            <a:r>
+              <a:rPr dirty="0" err="1"/>
+              <a:t>problemene</a:t>
+            </a:r>
+            <a:r>
+              <a:rPr dirty="0"/>
+              <a:t> </a:t>
+            </a:r>
+            <a:r>
+              <a:rPr dirty="0" err="1"/>
+              <a:t>deres</a:t>
+            </a:r>
+            <a:endParaRPr dirty="0"/>
+          </a:p>
+        </p:txBody>
+      </p:sp>
+    </p:spTree>
+  </p:cSld>
+  <p:clrMapOvr>
+    <a:masterClrMapping/>
+  </p:clrMapOvr>
+</p:sld>
+</file>
+
 <file path=ppt/slides/slide4.xml><?xml version="1.0" encoding="utf-8"?>
 <p:sld xmlns:a="http://schemas.openxmlformats.org/drawingml/2006/main" xmlns:r="http://schemas.openxmlformats.org/officeDocument/2006/relationships" xmlns:p="http://schemas.openxmlformats.org/presentationml/2006/main">
   <p:cSld>
@@ -17504,412 +17272,6 @@
           <a:lstStyle/>
           <a:p>
             <a:r>
-              <a:t>LLM-problemer for forskere</a:t>
-            </a:r>
-          </a:p>
-        </p:txBody>
-      </p:sp>
-      <p:sp>
-        <p:nvSpPr>
-          <p:cNvPr id="3" name="Content Placeholder 2"/>
-          <p:cNvSpPr>
-            <a:spLocks noGrp="1"/>
-          </p:cNvSpPr>
-          <p:nvPr>
-            <p:ph idx="1"/>
-          </p:nvPr>
-        </p:nvSpPr>
-        <p:spPr>
-          <a:xfrm>
-            <a:off x="1015459" y="2177396"/>
-            <a:ext cx="10515600" cy="4191320"/>
-          </a:xfrm>
-        </p:spPr>
-        <p:txBody>
-          <a:bodyPr>
-            <a:normAutofit fontScale="92500"/>
-          </a:bodyPr>
-          <a:lstStyle/>
-          <a:p>
-            <a:pPr lvl="0"/>
-            <a:r>
-              <a:rPr dirty="0"/>
-              <a:t>LLM-er er </a:t>
-            </a:r>
-            <a:r>
-              <a:rPr b="1" dirty="0" err="1"/>
-              <a:t>prediksjons</a:t>
-            </a:r>
-            <a:r>
-              <a:rPr b="1" dirty="0"/>
-              <a:t>-/</a:t>
-            </a:r>
-            <a:r>
-              <a:rPr b="1" dirty="0" err="1"/>
-              <a:t>interpolasjonsmaskiner</a:t>
-            </a:r>
-            <a:r>
-              <a:rPr dirty="0"/>
-              <a:t>: De </a:t>
-            </a:r>
-            <a:r>
-              <a:rPr dirty="0" err="1"/>
-              <a:t>modellerer</a:t>
-            </a:r>
-            <a:r>
-              <a:rPr dirty="0"/>
-              <a:t> den </a:t>
-            </a:r>
-            <a:r>
-              <a:rPr dirty="0" err="1"/>
-              <a:t>temporale</a:t>
-            </a:r>
-            <a:r>
-              <a:rPr dirty="0"/>
-              <a:t> </a:t>
-            </a:r>
-            <a:r>
-              <a:rPr dirty="0" err="1"/>
-              <a:t>rekkefølgen</a:t>
-            </a:r>
-            <a:r>
-              <a:rPr dirty="0"/>
-              <a:t> </a:t>
-            </a:r>
-            <a:r>
-              <a:rPr dirty="0" err="1"/>
-              <a:t>til</a:t>
-            </a:r>
-            <a:r>
-              <a:rPr dirty="0"/>
-              <a:t> tokens (</a:t>
-            </a:r>
-            <a:r>
-              <a:rPr dirty="0" err="1"/>
-              <a:t>ord</a:t>
-            </a:r>
-            <a:r>
-              <a:rPr lang="nb-NO" dirty="0"/>
-              <a:t>eler</a:t>
-            </a:r>
-            <a:r>
-              <a:rPr dirty="0"/>
-              <a:t>)</a:t>
-            </a:r>
-          </a:p>
-          <a:p>
-            <a:pPr lvl="0"/>
-            <a:r>
-              <a:rPr dirty="0"/>
-              <a:t>Dette er </a:t>
-            </a:r>
-            <a:r>
-              <a:rPr b="1" dirty="0" err="1"/>
-              <a:t>svært</a:t>
-            </a:r>
-            <a:r>
-              <a:rPr b="1" dirty="0"/>
-              <a:t> </a:t>
-            </a:r>
-            <a:r>
-              <a:rPr b="1" dirty="0" err="1"/>
-              <a:t>nyttig</a:t>
-            </a:r>
-            <a:r>
-              <a:rPr dirty="0"/>
-              <a:t>, </a:t>
-            </a:r>
-            <a:r>
-              <a:rPr dirty="0" err="1"/>
-              <a:t>fordi</a:t>
-            </a:r>
-            <a:r>
-              <a:rPr dirty="0"/>
-              <a:t> </a:t>
-            </a:r>
-            <a:r>
-              <a:rPr dirty="0" err="1"/>
-              <a:t>riktig</a:t>
-            </a:r>
-            <a:r>
-              <a:rPr dirty="0"/>
-              <a:t> </a:t>
-            </a:r>
-            <a:r>
-              <a:rPr dirty="0" err="1"/>
-              <a:t>ordnede</a:t>
-            </a:r>
-            <a:r>
-              <a:rPr dirty="0"/>
-              <a:t> </a:t>
-            </a:r>
-            <a:r>
-              <a:rPr dirty="0" err="1"/>
-              <a:t>ord</a:t>
-            </a:r>
-            <a:r>
-              <a:rPr dirty="0"/>
-              <a:t> </a:t>
-            </a:r>
-            <a:r>
-              <a:rPr dirty="0" err="1"/>
-              <a:t>faktisk</a:t>
-            </a:r>
-            <a:r>
-              <a:rPr dirty="0"/>
-              <a:t> </a:t>
-            </a:r>
-            <a:r>
-              <a:rPr dirty="0" err="1"/>
-              <a:t>inneholder</a:t>
-            </a:r>
-            <a:r>
-              <a:rPr dirty="0"/>
-              <a:t> </a:t>
-            </a:r>
-            <a:r>
-              <a:rPr dirty="0" err="1"/>
-              <a:t>mening</a:t>
-            </a:r>
-            <a:endParaRPr dirty="0"/>
-          </a:p>
-          <a:p>
-            <a:pPr lvl="0"/>
-            <a:r>
-              <a:rPr dirty="0"/>
-              <a:t>Men </a:t>
-            </a:r>
-            <a:r>
-              <a:rPr dirty="0" err="1"/>
-              <a:t>måten</a:t>
-            </a:r>
-            <a:r>
-              <a:rPr dirty="0"/>
-              <a:t> LLM-er er </a:t>
-            </a:r>
-            <a:r>
-              <a:rPr dirty="0" err="1"/>
-              <a:t>bygget</a:t>
-            </a:r>
-            <a:r>
-              <a:rPr dirty="0"/>
-              <a:t> </a:t>
-            </a:r>
-            <a:r>
-              <a:rPr dirty="0" err="1"/>
-              <a:t>på</a:t>
-            </a:r>
-            <a:r>
-              <a:rPr dirty="0"/>
-              <a:t> </a:t>
-            </a:r>
-            <a:r>
-              <a:rPr dirty="0" err="1"/>
-              <a:t>skaper</a:t>
-            </a:r>
-            <a:r>
-              <a:rPr dirty="0"/>
-              <a:t> 2 </a:t>
-            </a:r>
-            <a:r>
-              <a:rPr dirty="0" err="1"/>
-              <a:t>problemer</a:t>
-            </a:r>
-            <a:r>
-              <a:rPr dirty="0"/>
-              <a:t> for </a:t>
-            </a:r>
-            <a:r>
-              <a:rPr dirty="0" err="1"/>
-              <a:t>forskere</a:t>
-            </a:r>
-            <a:r>
-              <a:rPr dirty="0"/>
-              <a:t> </a:t>
-            </a:r>
-            <a:r>
-              <a:rPr dirty="0" err="1"/>
-              <a:t>når</a:t>
-            </a:r>
-            <a:r>
-              <a:rPr dirty="0"/>
-              <a:t> «nye» </a:t>
-            </a:r>
-            <a:r>
-              <a:rPr dirty="0" err="1"/>
-              <a:t>ordrekker</a:t>
-            </a:r>
-            <a:r>
-              <a:rPr dirty="0"/>
-              <a:t> </a:t>
-            </a:r>
-            <a:r>
-              <a:rPr dirty="0" err="1"/>
-              <a:t>genereres</a:t>
-            </a:r>
-            <a:endParaRPr dirty="0"/>
-          </a:p>
-          <a:p>
-            <a:pPr lvl="1"/>
-            <a:r>
-              <a:rPr b="1" dirty="0" err="1"/>
-              <a:t>Regresjon</a:t>
-            </a:r>
-            <a:r>
-              <a:rPr b="1" dirty="0"/>
-              <a:t> mot </a:t>
-            </a:r>
-            <a:r>
-              <a:rPr b="1" dirty="0" err="1"/>
-              <a:t>modalverdien</a:t>
-            </a:r>
-            <a:r>
-              <a:rPr dirty="0"/>
-              <a:t> </a:t>
-            </a:r>
-            <a:r>
-              <a:rPr dirty="0" err="1"/>
-              <a:t>i</a:t>
-            </a:r>
-            <a:r>
-              <a:rPr dirty="0"/>
-              <a:t> </a:t>
-            </a:r>
-            <a:r>
-              <a:rPr dirty="0" err="1"/>
-              <a:t>treningsdataene</a:t>
-            </a:r>
-            <a:endParaRPr dirty="0"/>
-          </a:p>
-          <a:p>
-            <a:pPr lvl="1"/>
-            <a:r>
-              <a:rPr b="1" dirty="0" err="1"/>
-              <a:t>Hallusinasjon</a:t>
-            </a:r>
-            <a:endParaRPr b="1" dirty="0"/>
-          </a:p>
-          <a:p>
-            <a:pPr marL="0" indent="0">
-              <a:buNone/>
-            </a:pPr>
-            <a:r>
-              <a:rPr dirty="0"/>
-              <a:t>Som </a:t>
-            </a:r>
-            <a:r>
-              <a:rPr dirty="0" err="1"/>
-              <a:t>forskere</a:t>
-            </a:r>
-            <a:r>
-              <a:rPr dirty="0"/>
-              <a:t> </a:t>
-            </a:r>
-            <a:r>
-              <a:rPr dirty="0" err="1"/>
-              <a:t>ønsker</a:t>
-            </a:r>
-            <a:r>
-              <a:rPr dirty="0"/>
-              <a:t> vi å </a:t>
-            </a:r>
-            <a:r>
-              <a:rPr dirty="0" err="1"/>
-              <a:t>utnytte</a:t>
-            </a:r>
-            <a:r>
-              <a:rPr dirty="0"/>
-              <a:t> </a:t>
-            </a:r>
-            <a:r>
-              <a:rPr dirty="0" err="1"/>
-              <a:t>nytten</a:t>
-            </a:r>
-            <a:r>
-              <a:rPr dirty="0"/>
-              <a:t> av LLM-er </a:t>
-            </a:r>
-            <a:r>
-              <a:rPr dirty="0" err="1"/>
-              <a:t>samtidig</a:t>
-            </a:r>
-            <a:r>
-              <a:rPr dirty="0"/>
-              <a:t> </a:t>
-            </a:r>
-            <a:r>
-              <a:rPr dirty="0" err="1"/>
-              <a:t>som</a:t>
-            </a:r>
-            <a:r>
-              <a:rPr dirty="0"/>
-              <a:t> vi </a:t>
-            </a:r>
-            <a:r>
-              <a:rPr dirty="0" err="1"/>
-              <a:t>kontrollerer</a:t>
-            </a:r>
-            <a:r>
-              <a:rPr dirty="0"/>
-              <a:t> </a:t>
-            </a:r>
-            <a:r>
-              <a:rPr dirty="0" err="1"/>
-              <a:t>problemene</a:t>
-            </a:r>
-            <a:r>
-              <a:rPr dirty="0"/>
-              <a:t> </a:t>
-            </a:r>
-            <a:r>
-              <a:rPr dirty="0" err="1"/>
-              <a:t>deres</a:t>
-            </a:r>
-            <a:endParaRPr dirty="0"/>
-          </a:p>
-        </p:txBody>
-      </p:sp>
-    </p:spTree>
-  </p:cSld>
-  <p:clrMapOvr>
-    <a:masterClrMapping/>
-  </p:clrMapOvr>
-</p:sld>
-</file>
-
-<file path=ppt/slides/slide5.xml><?xml version="1.0" encoding="utf-8"?>
-<p:sld xmlns:a="http://schemas.openxmlformats.org/drawingml/2006/main" xmlns:r="http://schemas.openxmlformats.org/officeDocument/2006/relationships" xmlns:p="http://schemas.openxmlformats.org/presentationml/2006/main">
-  <p:cSld>
-    <p:spTree>
-      <p:nvGrpSpPr>
-        <p:cNvPr id="1" name=""/>
-        <p:cNvGrpSpPr/>
-        <p:nvPr/>
-      </p:nvGrpSpPr>
-      <p:grpSpPr>
-        <a:xfrm>
-          <a:off x="0" y="0"/>
-          <a:ext cx="0" cy="0"/>
-          <a:chOff x="0" y="0"/>
-          <a:chExt cx="0" cy="0"/>
-        </a:xfrm>
-      </p:grpSpPr>
-      <p:sp>
-        <p:nvSpPr>
-          <p:cNvPr id="2" name="Title 1"/>
-          <p:cNvSpPr>
-            <a:spLocks noGrp="1"/>
-          </p:cNvSpPr>
-          <p:nvPr>
-            <p:ph type="title"/>
-          </p:nvPr>
-        </p:nvSpPr>
-        <p:spPr/>
-        <p:txBody>
-          <a:bodyPr/>
-          <a:lstStyle/>
-          <a:p>
-            <a:r>
               <a:t>Løsninger på LLM-problemer</a:t>
             </a:r>
           </a:p>
@@ -18126,7 +17488,7 @@
 </p:sld>
 </file>
 
-<file path=ppt/slides/slide6.xml><?xml version="1.0" encoding="utf-8"?>
+<file path=ppt/slides/slide5.xml><?xml version="1.0" encoding="utf-8"?>
 <p:sld xmlns:a="http://schemas.openxmlformats.org/drawingml/2006/main" xmlns:r="http://schemas.openxmlformats.org/officeDocument/2006/relationships" xmlns:p="http://schemas.openxmlformats.org/presentationml/2006/main">
   <p:cSld>
     <p:spTree>
@@ -18847,7 +18209,7 @@
 </p:sld>
 </file>
 
-<file path=ppt/slides/slide7.xml><?xml version="1.0" encoding="utf-8"?>
+<file path=ppt/slides/slide6.xml><?xml version="1.0" encoding="utf-8"?>
 <p:sld xmlns:a="http://schemas.openxmlformats.org/drawingml/2006/main" xmlns:r="http://schemas.openxmlformats.org/officeDocument/2006/relationships" xmlns:p="http://schemas.openxmlformats.org/presentationml/2006/main">
   <p:cSld>
     <p:spTree>
@@ -19351,7 +18713,7 @@
 </p:sld>
 </file>
 
-<file path=ppt/slides/slide8.xml><?xml version="1.0" encoding="utf-8"?>
+<file path=ppt/slides/slide7.xml><?xml version="1.0" encoding="utf-8"?>
 <p:sld xmlns:a="http://schemas.openxmlformats.org/drawingml/2006/main" xmlns:r="http://schemas.openxmlformats.org/officeDocument/2006/relationships" xmlns:p="http://schemas.openxmlformats.org/presentationml/2006/main">
   <p:cSld>
     <p:spTree>
@@ -20156,6 +19518,354 @@
 </p:sld>
 </file>
 
+<file path=ppt/slides/slide8.xml><?xml version="1.0" encoding="utf-8"?>
+<p:sld xmlns:a="http://schemas.openxmlformats.org/drawingml/2006/main" xmlns:r="http://schemas.openxmlformats.org/officeDocument/2006/relationships" xmlns:p="http://schemas.openxmlformats.org/presentationml/2006/main">
+  <p:cSld>
+    <p:spTree>
+      <p:nvGrpSpPr>
+        <p:cNvPr id="1" name=""/>
+        <p:cNvGrpSpPr/>
+        <p:nvPr/>
+      </p:nvGrpSpPr>
+      <p:grpSpPr>
+        <a:xfrm>
+          <a:off x="0" y="0"/>
+          <a:ext cx="0" cy="0"/>
+          <a:chOff x="0" y="0"/>
+          <a:chExt cx="0" cy="0"/>
+        </a:xfrm>
+      </p:grpSpPr>
+      <p:sp>
+        <p:nvSpPr>
+          <p:cNvPr id="2" name="Title 1"/>
+          <p:cNvSpPr>
+            <a:spLocks noGrp="1"/>
+          </p:cNvSpPr>
+          <p:nvPr>
+            <p:ph type="title"/>
+          </p:nvPr>
+        </p:nvSpPr>
+        <p:spPr/>
+        <p:txBody>
+          <a:bodyPr/>
+          <a:lstStyle/>
+          <a:p>
+            <a:r>
+              <a:t>Tekstgenerering med verifisering</a:t>
+            </a:r>
+          </a:p>
+        </p:txBody>
+      </p:sp>
+      <p:sp>
+        <p:nvSpPr>
+          <p:cNvPr id="3" name="Content Placeholder 2"/>
+          <p:cNvSpPr>
+            <a:spLocks noGrp="1"/>
+          </p:cNvSpPr>
+          <p:nvPr>
+            <p:ph idx="1"/>
+          </p:nvPr>
+        </p:nvSpPr>
+        <p:spPr/>
+        <p:txBody>
+          <a:bodyPr/>
+          <a:lstStyle/>
+          <a:p>
+            <a:pPr lvl="0"/>
+            <a:r>
+              <a:rPr dirty="0" err="1"/>
+              <a:t>Rapporter</a:t>
+            </a:r>
+            <a:r>
+              <a:rPr dirty="0"/>
+              <a:t> for </a:t>
+            </a:r>
+            <a:r>
+              <a:rPr dirty="0" err="1"/>
+              <a:t>hundrevis</a:t>
+            </a:r>
+            <a:r>
+              <a:rPr dirty="0"/>
+              <a:t> av </a:t>
+            </a:r>
+            <a:r>
+              <a:rPr dirty="0" err="1"/>
+              <a:t>kommuner</a:t>
+            </a:r>
+            <a:r>
+              <a:rPr dirty="0"/>
+              <a:t>, </a:t>
+            </a:r>
+            <a:r>
+              <a:rPr dirty="0" err="1"/>
+              <a:t>skoler</a:t>
+            </a:r>
+            <a:r>
+              <a:rPr dirty="0"/>
+              <a:t>, … — å </a:t>
+            </a:r>
+            <a:r>
+              <a:rPr dirty="0" err="1"/>
+              <a:t>skrive</a:t>
+            </a:r>
+            <a:r>
+              <a:rPr dirty="0"/>
+              <a:t> </a:t>
+            </a:r>
+            <a:r>
+              <a:rPr dirty="0" err="1"/>
+              <a:t>undergruppespecifik</a:t>
+            </a:r>
+            <a:r>
+              <a:rPr dirty="0"/>
+              <a:t> </a:t>
+            </a:r>
+            <a:r>
+              <a:rPr dirty="0" err="1"/>
+              <a:t>tekst</a:t>
+            </a:r>
+            <a:r>
+              <a:rPr dirty="0"/>
+              <a:t> for </a:t>
+            </a:r>
+            <a:r>
+              <a:rPr dirty="0" err="1"/>
+              <a:t>hånd</a:t>
+            </a:r>
+            <a:r>
+              <a:rPr dirty="0"/>
+              <a:t> </a:t>
+            </a:r>
+            <a:r>
+              <a:rPr dirty="0" err="1"/>
+              <a:t>skalerer</a:t>
+            </a:r>
+            <a:r>
+              <a:rPr dirty="0"/>
+              <a:t> </a:t>
+            </a:r>
+            <a:r>
+              <a:rPr dirty="0" err="1"/>
+              <a:t>ikke</a:t>
+            </a:r>
+            <a:endParaRPr dirty="0"/>
+          </a:p>
+          <a:p>
+            <a:pPr lvl="0"/>
+            <a:r>
+              <a:rPr dirty="0"/>
+              <a:t>LLM-er </a:t>
+            </a:r>
+            <a:r>
+              <a:rPr dirty="0" err="1"/>
+              <a:t>kan</a:t>
+            </a:r>
+            <a:r>
+              <a:rPr dirty="0"/>
+              <a:t> </a:t>
+            </a:r>
+            <a:r>
+              <a:rPr dirty="0" err="1"/>
+              <a:t>generere</a:t>
+            </a:r>
+            <a:r>
+              <a:rPr dirty="0"/>
+              <a:t> </a:t>
+            </a:r>
+            <a:r>
+              <a:rPr dirty="0" err="1"/>
+              <a:t>denne</a:t>
+            </a:r>
+            <a:r>
+              <a:rPr dirty="0"/>
+              <a:t> </a:t>
+            </a:r>
+            <a:r>
+              <a:rPr dirty="0" err="1"/>
+              <a:t>teksten</a:t>
+            </a:r>
+            <a:r>
+              <a:rPr dirty="0"/>
+              <a:t> </a:t>
+            </a:r>
+            <a:r>
+              <a:rPr dirty="0" err="1"/>
+              <a:t>automatisk</a:t>
+            </a:r>
+            <a:r>
+              <a:rPr dirty="0"/>
+              <a:t> </a:t>
+            </a:r>
+            <a:r>
+              <a:rPr dirty="0" err="1"/>
+              <a:t>fra</a:t>
+            </a:r>
+            <a:r>
+              <a:rPr dirty="0"/>
+              <a:t> </a:t>
+            </a:r>
+            <a:r>
+              <a:rPr dirty="0" err="1"/>
+              <a:t>statistiske</a:t>
+            </a:r>
+            <a:r>
+              <a:rPr dirty="0"/>
+              <a:t> </a:t>
+            </a:r>
+            <a:r>
+              <a:rPr dirty="0" err="1"/>
+              <a:t>tabeller</a:t>
+            </a:r>
+            <a:endParaRPr dirty="0"/>
+          </a:p>
+          <a:p>
+            <a:pPr lvl="0"/>
+            <a:r>
+              <a:rPr dirty="0" err="1"/>
+              <a:t>Også</a:t>
+            </a:r>
+            <a:r>
+              <a:rPr dirty="0"/>
+              <a:t> </a:t>
+            </a:r>
+            <a:r>
+              <a:rPr dirty="0" err="1"/>
+              <a:t>nyttig</a:t>
+            </a:r>
+            <a:r>
+              <a:rPr dirty="0"/>
+              <a:t> for å </a:t>
+            </a:r>
+            <a:r>
+              <a:rPr dirty="0" err="1"/>
+              <a:t>utarbeide</a:t>
+            </a:r>
+            <a:r>
+              <a:rPr dirty="0"/>
+              <a:t> </a:t>
+            </a:r>
+            <a:r>
+              <a:rPr dirty="0" err="1"/>
+              <a:t>resultatdeler</a:t>
+            </a:r>
+            <a:r>
+              <a:rPr dirty="0"/>
+              <a:t> </a:t>
+            </a:r>
+            <a:r>
+              <a:rPr dirty="0" err="1"/>
+              <a:t>fra</a:t>
+            </a:r>
+            <a:r>
+              <a:rPr dirty="0"/>
+              <a:t> </a:t>
+            </a:r>
+            <a:r>
+              <a:rPr dirty="0" err="1"/>
+              <a:t>analyseresultater</a:t>
+            </a:r>
+            <a:endParaRPr dirty="0"/>
+          </a:p>
+          <a:p>
+            <a:pPr lvl="0"/>
+            <a:r>
+              <a:rPr dirty="0"/>
+              <a:t>Risiko: </a:t>
+            </a:r>
+            <a:r>
+              <a:rPr dirty="0" err="1"/>
+              <a:t>Hallusinasjon</a:t>
+            </a:r>
+            <a:r>
+              <a:rPr dirty="0"/>
+              <a:t> av tall: </a:t>
+            </a:r>
+            <a:r>
+              <a:rPr b="1" dirty="0" err="1"/>
+              <a:t>programmatisk</a:t>
+            </a:r>
+            <a:r>
+              <a:rPr b="1" dirty="0"/>
+              <a:t> </a:t>
+            </a:r>
+            <a:r>
+              <a:rPr b="1" dirty="0" err="1"/>
+              <a:t>verifisering</a:t>
+            </a:r>
+            <a:endParaRPr b="1" dirty="0"/>
+          </a:p>
+          <a:p>
+            <a:pPr lvl="0"/>
+            <a:r>
+              <a:rPr dirty="0"/>
+              <a:t>I R: </a:t>
+            </a:r>
+            <a:r>
+              <a:rPr dirty="0" err="1">
+                <a:latin typeface="Courier"/>
+              </a:rPr>
+              <a:t>tblscribe</a:t>
+            </a:r>
+            <a:br>
+              <a:rPr lang="nb-NO" dirty="0">
+                <a:latin typeface="Courier"/>
+              </a:rPr>
+            </a:br>
+            <a:r>
+              <a:rPr dirty="0"/>
+              <a:t>(</a:t>
+            </a:r>
+            <a:r>
+              <a:rPr dirty="0" err="1"/>
+              <a:t>sammenligner</a:t>
+            </a:r>
+            <a:r>
+              <a:rPr dirty="0"/>
+              <a:t> tall </a:t>
+            </a:r>
+            <a:r>
+              <a:rPr dirty="0" err="1"/>
+              <a:t>i</a:t>
+            </a:r>
+            <a:r>
+              <a:rPr dirty="0"/>
+              <a:t> </a:t>
+            </a:r>
+            <a:r>
+              <a:rPr dirty="0" err="1"/>
+              <a:t>generert</a:t>
+            </a:r>
+            <a:r>
+              <a:rPr dirty="0"/>
+              <a:t> </a:t>
+            </a:r>
+            <a:r>
+              <a:rPr dirty="0" err="1"/>
+              <a:t>tekst</a:t>
+            </a:r>
+            <a:r>
+              <a:rPr dirty="0"/>
+              <a:t> mot </a:t>
+            </a:r>
+            <a:r>
+              <a:rPr dirty="0" err="1"/>
+              <a:t>kildetabellen</a:t>
+            </a:r>
+            <a:r>
+              <a:rPr dirty="0"/>
+              <a:t>)</a:t>
+            </a:r>
+          </a:p>
+        </p:txBody>
+      </p:sp>
+    </p:spTree>
+  </p:cSld>
+  <p:clrMapOvr>
+    <a:masterClrMapping/>
+  </p:clrMapOvr>
+</p:sld>
+</file>
+
 <file path=ppt/slides/slide9.xml><?xml version="1.0" encoding="utf-8"?>
 <p:sld xmlns:a="http://schemas.openxmlformats.org/drawingml/2006/main" xmlns:r="http://schemas.openxmlformats.org/officeDocument/2006/relationships" xmlns:p="http://schemas.openxmlformats.org/presentationml/2006/main">
   <p:cSld>
@@ -20189,7 +19899,7 @@
           <a:lstStyle/>
           <a:p>
             <a:r>
-              <a:t>Tekstgenerering med verifisering</a:t>
+              <a:t>Agentbaserte systemer</a:t>
             </a:r>
           </a:p>
         </p:txBody>
@@ -20201,34 +19911,88 @@
             <a:spLocks noGrp="1"/>
           </p:cNvSpPr>
           <p:nvPr>
-            <p:ph idx="1"/>
+            <p:ph sz="half" idx="1"/>
           </p:nvPr>
         </p:nvSpPr>
-        <p:spPr/>
+        <p:spPr>
+          <a:xfrm>
+            <a:off x="609599" y="1600201"/>
+            <a:ext cx="6304444" cy="4525963"/>
+          </a:xfrm>
+        </p:spPr>
         <p:txBody>
-          <a:bodyPr/>
+          <a:bodyPr>
+            <a:normAutofit lnSpcReduction="10000"/>
+          </a:bodyPr>
           <a:lstStyle/>
           <a:p>
             <a:pPr lvl="0"/>
             <a:r>
               <a:rPr dirty="0" err="1"/>
-              <a:t>Rapporter</a:t>
+              <a:t>Planlegger</a:t>
             </a:r>
             <a:r>
               <a:rPr dirty="0"/>
-              <a:t> for </a:t>
+              <a:t> </a:t>
             </a:r>
             <a:r>
               <a:rPr dirty="0" err="1"/>
-              <a:t>hundrevis</a:t>
+              <a:t>og</a:t>
             </a:r>
             <a:r>
               <a:rPr dirty="0"/>
-              <a:t> av </a:t>
+              <a:t> </a:t>
             </a:r>
             <a:r>
               <a:rPr dirty="0" err="1"/>
-              <a:t>kommuner</a:t>
+              <a:t>gjennomfører</a:t>
+            </a:r>
+            <a:r>
+              <a:rPr dirty="0"/>
+              <a:t> </a:t>
+            </a:r>
+            <a:r>
+              <a:rPr dirty="0" err="1"/>
+              <a:t>flertrinnsoppgaver</a:t>
+            </a:r>
+            <a:r>
+              <a:rPr dirty="0"/>
+              <a:t> med minimal input.</a:t>
+            </a:r>
+          </a:p>
+          <a:p>
+            <a:pPr lvl="0"/>
+            <a:r>
+              <a:rPr dirty="0"/>
+              <a:t>Kan </a:t>
+            </a:r>
+            <a:r>
+              <a:rPr dirty="0" err="1"/>
+              <a:t>bruke</a:t>
+            </a:r>
+            <a:r>
+              <a:rPr dirty="0"/>
+              <a:t> </a:t>
+            </a:r>
+            <a:r>
+              <a:rPr dirty="0" err="1"/>
+              <a:t>eksterne</a:t>
+            </a:r>
+            <a:r>
+              <a:rPr dirty="0"/>
+              <a:t> </a:t>
+            </a:r>
+            <a:r>
+              <a:rPr dirty="0" err="1"/>
+              <a:t>verktøy</a:t>
+            </a:r>
+            <a:r>
+              <a:rPr dirty="0"/>
+              <a:t>: </a:t>
+            </a:r>
+            <a:r>
+              <a:rPr dirty="0" err="1"/>
+              <a:t>nettsøk</a:t>
             </a:r>
             <a:r>
               <a:rPr dirty="0"/>
@@ -20236,15 +20000,15 @@
             </a:r>
             <a:r>
               <a:rPr dirty="0" err="1"/>
-              <a:t>skoler</a:t>
+              <a:t>filsystem</a:t>
             </a:r>
             <a:r>
               <a:rPr dirty="0"/>
-              <a:t>, … — å </a:t>
+              <a:t>, </a:t>
             </a:r>
             <a:r>
               <a:rPr dirty="0" err="1"/>
-              <a:t>skrive</a:t>
+              <a:t>databaser</a:t>
             </a:r>
             <a:r>
               <a:rPr dirty="0"/>
@@ -20252,7 +20016,61 @@
             </a:r>
             <a:r>
               <a:rPr dirty="0" err="1"/>
-              <a:t>undergruppespecifik</a:t>
+              <a:t>og</a:t>
+            </a:r>
+            <a:r>
+              <a:rPr dirty="0"/>
+              <a:t> API-er.</a:t>
+            </a:r>
+          </a:p>
+          <a:p>
+            <a:pPr lvl="0"/>
+            <a:r>
+              <a:rPr b="1" dirty="0"/>
+              <a:t>Skriver </a:t>
+            </a:r>
+            <a:r>
+              <a:rPr b="1" dirty="0" err="1"/>
+              <a:t>og</a:t>
+            </a:r>
+            <a:r>
+              <a:rPr b="1" dirty="0"/>
+              <a:t> </a:t>
+            </a:r>
+            <a:r>
+              <a:rPr b="1" dirty="0" err="1"/>
+              <a:t>kjører</a:t>
+            </a:r>
+            <a:r>
+              <a:rPr b="1" dirty="0"/>
+              <a:t> </a:t>
+            </a:r>
+            <a:r>
+              <a:rPr b="1" dirty="0" err="1"/>
+              <a:t>kode</a:t>
+            </a:r>
+            <a:r>
+              <a:rPr b="1" dirty="0"/>
+              <a:t>.</a:t>
+            </a:r>
+          </a:p>
+          <a:p>
+            <a:pPr lvl="0"/>
+            <a:r>
+              <a:rPr dirty="0"/>
+              <a:t>Arbeider </a:t>
+            </a:r>
+            <a:r>
+              <a:rPr dirty="0" err="1"/>
+              <a:t>iterativt</a:t>
+            </a:r>
+            <a:r>
+              <a:rPr dirty="0"/>
+              <a:t> — </a:t>
+            </a:r>
+            <a:r>
+              <a:rPr dirty="0" err="1"/>
+              <a:t>kjører</a:t>
             </a:r>
             <a:r>
               <a:rPr dirty="0"/>
@@ -20260,15 +20078,15 @@
             </a:r>
             <a:r>
               <a:rPr dirty="0" err="1"/>
-              <a:t>tekst</a:t>
+              <a:t>kode</a:t>
             </a:r>
             <a:r>
               <a:rPr dirty="0"/>
-              <a:t> for </a:t>
+              <a:t>, </a:t>
             </a:r>
             <a:r>
               <a:rPr dirty="0" err="1"/>
-              <a:t>hånd</a:t>
+              <a:t>leser</a:t>
             </a:r>
             <a:r>
               <a:rPr dirty="0"/>
@@ -20276,7 +20094,7 @@
             </a:r>
             <a:r>
               <a:rPr dirty="0" err="1"/>
-              <a:t>skalerer</a:t>
+              <a:t>feil</a:t>
             </a:r>
             <a:r>
               <a:rPr dirty="0"/>
@@ -20284,15 +20102,50 @@
             </a:r>
             <a:r>
               <a:rPr dirty="0" err="1"/>
-              <a:t>ikke</a:t>
-            </a:r>
-            <a:endParaRPr dirty="0"/>
+              <a:t>og</a:t>
+            </a:r>
+            <a:r>
+              <a:rPr dirty="0"/>
+              <a:t> </a:t>
+            </a:r>
+            <a:r>
+              <a:rPr b="1" dirty="0" err="1"/>
+              <a:t>korrigerer</a:t>
+            </a:r>
+            <a:r>
+              <a:rPr b="1" dirty="0"/>
+              <a:t> seg </a:t>
+            </a:r>
+            <a:r>
+              <a:rPr b="1" dirty="0" err="1"/>
+              <a:t>selv</a:t>
+            </a:r>
+            <a:r>
+              <a:rPr dirty="0"/>
+              <a:t>.</a:t>
+            </a:r>
           </a:p>
           <a:p>
             <a:pPr lvl="0"/>
             <a:r>
               <a:rPr dirty="0"/>
-              <a:t>LLM-er </a:t>
+              <a:t>Mest </a:t>
+            </a:r>
+            <a:r>
+              <a:rPr dirty="0" err="1"/>
+              <a:t>effektivt</a:t>
+            </a:r>
+            <a:r>
+              <a:rPr dirty="0"/>
+              <a:t> </a:t>
+            </a:r>
+            <a:r>
+              <a:rPr dirty="0" err="1"/>
+              <a:t>når</a:t>
+            </a:r>
+            <a:r>
+              <a:rPr dirty="0"/>
+              <a:t> du </a:t>
             </a:r>
             <a:r>
               <a:rPr dirty="0" err="1"/>
@@ -20304,194 +20157,98 @@
             </a:r>
             <a:r>
               <a:rPr dirty="0" err="1"/>
-              <a:t>generere</a:t>
+              <a:t>vurdere</a:t>
             </a:r>
             <a:r>
               <a:rPr dirty="0"/>
-              <a:t> </a:t>
+              <a:t> om </a:t>
             </a:r>
             <a:r>
               <a:rPr dirty="0" err="1"/>
-              <a:t>denne</a:t>
+              <a:t>resultatet</a:t>
             </a:r>
             <a:r>
               <a:rPr dirty="0"/>
-              <a:t> </a:t>
+              <a:t> er </a:t>
             </a:r>
             <a:r>
               <a:rPr dirty="0" err="1"/>
-              <a:t>teksten</a:t>
+              <a:t>korrekt</a:t>
             </a:r>
             <a:r>
               <a:rPr dirty="0"/>
-              <a:t> </a:t>
-            </a:r>
-            <a:r>
-              <a:rPr dirty="0" err="1"/>
-              <a:t>automatisk</a:t>
-            </a:r>
-            <a:r>
-              <a:rPr dirty="0"/>
-              <a:t> </a:t>
-            </a:r>
-            <a:r>
-              <a:rPr dirty="0" err="1"/>
-              <a:t>fra</a:t>
-            </a:r>
-            <a:r>
-              <a:rPr dirty="0"/>
-              <a:t> </a:t>
-            </a:r>
-            <a:r>
-              <a:rPr dirty="0" err="1"/>
-              <a:t>statistiske</a:t>
-            </a:r>
-            <a:r>
-              <a:rPr dirty="0"/>
-              <a:t> </a:t>
-            </a:r>
-            <a:r>
-              <a:rPr dirty="0" err="1"/>
-              <a:t>tabeller</a:t>
-            </a:r>
-            <a:endParaRPr dirty="0"/>
-          </a:p>
+              <a:t>.</a:t>
+            </a:r>
+          </a:p>
+        </p:txBody>
+      </p:sp>
+      <p:sp>
+        <p:nvSpPr>
+          <p:cNvPr id="4" name="Content Placeholder 3"/>
+          <p:cNvSpPr>
+            <a:spLocks noGrp="1"/>
+          </p:cNvSpPr>
+          <p:nvPr>
+            <p:ph sz="half" idx="2"/>
+          </p:nvPr>
+        </p:nvSpPr>
+        <p:spPr>
+          <a:xfrm>
+            <a:off x="7026443" y="1600202"/>
+            <a:ext cx="4555958" cy="2249904"/>
+          </a:xfrm>
+        </p:spPr>
+        <p:txBody>
+          <a:bodyPr>
+            <a:normAutofit lnSpcReduction="10000"/>
+          </a:bodyPr>
+          <a:lstStyle/>
           <a:p>
             <a:pPr lvl="0"/>
             <a:r>
-              <a:rPr dirty="0" err="1"/>
-              <a:t>Også</a:t>
-            </a:r>
-            <a:r>
-              <a:rPr dirty="0"/>
-              <a:t> </a:t>
-            </a:r>
-            <a:r>
-              <a:rPr dirty="0" err="1"/>
-              <a:t>nyttig</a:t>
-            </a:r>
-            <a:r>
-              <a:rPr dirty="0"/>
-              <a:t> for å </a:t>
-            </a:r>
-            <a:r>
-              <a:rPr dirty="0" err="1"/>
-              <a:t>utarbeide</a:t>
-            </a:r>
-            <a:r>
-              <a:rPr dirty="0"/>
-              <a:t> </a:t>
-            </a:r>
-            <a:r>
-              <a:rPr dirty="0" err="1"/>
-              <a:t>resultatdeler</a:t>
-            </a:r>
-            <a:r>
-              <a:rPr dirty="0"/>
-              <a:t> </a:t>
-            </a:r>
-            <a:r>
-              <a:rPr dirty="0" err="1"/>
-              <a:t>fra</a:t>
-            </a:r>
-            <a:r>
-              <a:rPr dirty="0"/>
-              <a:t> </a:t>
-            </a:r>
-            <a:r>
-              <a:rPr dirty="0" err="1"/>
-              <a:t>analyseresultater</a:t>
-            </a:r>
-            <a:endParaRPr dirty="0"/>
+              <a:rPr sz="1867" dirty="0"/>
+              <a:t>cursor.com</a:t>
+            </a:r>
           </a:p>
           <a:p>
             <a:pPr lvl="0"/>
             <a:r>
-              <a:rPr dirty="0"/>
-              <a:t>Risiko: </a:t>
-            </a:r>
-            <a:r>
-              <a:rPr dirty="0" err="1"/>
-              <a:t>Hallusinasjon</a:t>
-            </a:r>
-            <a:r>
-              <a:rPr dirty="0"/>
-              <a:t> av tall: </a:t>
-            </a:r>
-            <a:r>
-              <a:rPr b="1" dirty="0" err="1"/>
-              <a:t>programmatisk</a:t>
-            </a:r>
-            <a:r>
-              <a:rPr b="1" dirty="0"/>
-              <a:t> </a:t>
-            </a:r>
-            <a:r>
-              <a:rPr b="1" dirty="0" err="1"/>
-              <a:t>verifisering</a:t>
-            </a:r>
-            <a:endParaRPr b="1" dirty="0"/>
+              <a:rPr sz="1867" dirty="0"/>
+              <a:t>anthropic.com/product/</a:t>
+            </a:r>
+            <a:r>
+              <a:rPr sz="1867" dirty="0" err="1"/>
+              <a:t>claude</a:t>
+            </a:r>
+            <a:r>
+              <a:rPr sz="1867" dirty="0"/>
+              <a:t>-code</a:t>
+            </a:r>
           </a:p>
           <a:p>
             <a:pPr lvl="0"/>
             <a:r>
-              <a:rPr dirty="0"/>
-              <a:t>I R: </a:t>
-            </a:r>
-            <a:r>
-              <a:rPr dirty="0" err="1">
-                <a:latin typeface="Courier"/>
-              </a:rPr>
-              <a:t>tblscribe</a:t>
-            </a:r>
-            <a:br>
-              <a:rPr lang="nb-NO" dirty="0">
-                <a:latin typeface="Courier"/>
-              </a:rPr>
-            </a:br>
-            <a:r>
-              <a:rPr dirty="0"/>
-              <a:t>(</a:t>
-            </a:r>
-            <a:r>
-              <a:rPr dirty="0" err="1"/>
-              <a:t>sammenligner</a:t>
-            </a:r>
-            <a:r>
-              <a:rPr dirty="0"/>
-              <a:t> tall </a:t>
-            </a:r>
-            <a:r>
-              <a:rPr dirty="0" err="1"/>
-              <a:t>i</a:t>
-            </a:r>
-            <a:r>
-              <a:rPr dirty="0"/>
-              <a:t> </a:t>
-            </a:r>
-            <a:r>
-              <a:rPr dirty="0" err="1"/>
-              <a:t>generert</a:t>
-            </a:r>
-            <a:r>
-              <a:rPr dirty="0"/>
-              <a:t> </a:t>
-            </a:r>
-            <a:r>
-              <a:rPr dirty="0" err="1"/>
-              <a:t>tekst</a:t>
-            </a:r>
-            <a:r>
-              <a:rPr dirty="0"/>
-              <a:t> mot </a:t>
-            </a:r>
-            <a:r>
-              <a:rPr dirty="0" err="1"/>
-              <a:t>kildetabellen</a:t>
-            </a:r>
-            <a:r>
-              <a:rPr dirty="0"/>
-              <a:t>)</a:t>
+              <a:rPr sz="1867" dirty="0"/>
+              <a:t>anthropic.com/product/</a:t>
+            </a:r>
+            <a:r>
+              <a:rPr sz="1867" dirty="0" err="1"/>
+              <a:t>claude-cowork</a:t>
+            </a:r>
+            <a:endParaRPr sz="1867" dirty="0"/>
+          </a:p>
+          <a:p>
+            <a:pPr lvl="0"/>
+            <a:r>
+              <a:rPr sz="1867" dirty="0"/>
+              <a:t>https://antigravity.google/</a:t>
+            </a:r>
+          </a:p>
+          <a:p>
+            <a:pPr lvl="0"/>
+            <a:r>
+              <a:rPr sz="1867" dirty="0"/>
+              <a:t>…</a:t>
             </a:r>
           </a:p>
         </p:txBody>

</xml_diff>